<commit_message>
CKD 412, 427, 430, 456, 458, 459, 464
</commit_message>
<xml_diff>
--- a/CKDSurveillance/PPT/Q814.pptx
+++ b/CKDSurveillance/PPT/Q814.pptx
@@ -124,18 +124,77 @@
 </p:presentation>
 </file>
 
-<file path=ppt/revisionInfo.xml><?xml version="1.0" encoding="utf-8"?>
-<p1510:revInfo xmlns:a="http://schemas.openxmlformats.org/drawingml/2006/main" xmlns:r="http://schemas.openxmlformats.org/officeDocument/2006/relationships" xmlns:p1510="http://schemas.microsoft.com/office/powerpoint/2015/10/main">
-  <p1510:revLst>
-    <p1510:client id="{986E5C01-79D6-4C00-B85F-455552D05FD2}" v="10" dt="2025-10-17T20:44:14.290"/>
-    <p1510:client id="{B8FF97DB-82B8-4FF4-A98F-995759DBCEF1}" v="12" dt="2025-10-17T19:39:07.299"/>
-    <p1510:client id="{DCB07449-C7DF-4DB7-B43A-320A2FCCA54F}" v="40" dt="2025-10-17T19:58:00.100"/>
-  </p1510:revLst>
-</p1510:revInfo>
-</file>
-
 <file path=ppt/changesInfos/changesInfo1.xml><?xml version="1.0" encoding="utf-8"?>
 <pc:chgInfo xmlns:a="http://schemas.openxmlformats.org/drawingml/2006/main" xmlns:r="http://schemas.openxmlformats.org/officeDocument/2006/relationships" xmlns:ac="http://schemas.microsoft.com/office/drawing/2013/main/command" xmlns:pc="http://schemas.microsoft.com/office/powerpoint/2013/main/command">
+  <pc:docChgLst>
+    <pc:chgData name="Licon, Ana Laura" userId="cd5c2778-d82d-4d36-9d52-40772a6c9161" providerId="ADAL" clId="{7B3DC166-71B5-486B-9834-38074F2BBE65}"/>
+    <pc:docChg chg="custSel modSld">
+      <pc:chgData name="Licon, Ana Laura" userId="cd5c2778-d82d-4d36-9d52-40772a6c9161" providerId="ADAL" clId="{7B3DC166-71B5-486B-9834-38074F2BBE65}" dt="2025-11-18T22:32:43.875" v="20" actId="122"/>
+      <pc:docMkLst>
+        <pc:docMk/>
+      </pc:docMkLst>
+      <pc:sldChg chg="modSp mod">
+        <pc:chgData name="Licon, Ana Laura" userId="cd5c2778-d82d-4d36-9d52-40772a6c9161" providerId="ADAL" clId="{7B3DC166-71B5-486B-9834-38074F2BBE65}" dt="2025-11-18T22:32:43.875" v="20" actId="122"/>
+        <pc:sldMkLst>
+          <pc:docMk/>
+          <pc:sldMk cId="3654360913" sldId="256"/>
+        </pc:sldMkLst>
+        <pc:spChg chg="mod">
+          <ac:chgData name="Licon, Ana Laura" userId="cd5c2778-d82d-4d36-9d52-40772a6c9161" providerId="ADAL" clId="{7B3DC166-71B5-486B-9834-38074F2BBE65}" dt="2025-11-18T22:32:43.875" v="20" actId="122"/>
+          <ac:spMkLst>
+            <pc:docMk/>
+            <pc:sldMk cId="3654360913" sldId="256"/>
+            <ac:spMk id="2" creationId="{4CB0D1C1-F57F-8F26-3A27-C1F4D5FA7F05}"/>
+          </ac:spMkLst>
+        </pc:spChg>
+      </pc:sldChg>
+      <pc:sldChg chg="modSp mod">
+        <pc:chgData name="Licon, Ana Laura" userId="cd5c2778-d82d-4d36-9d52-40772a6c9161" providerId="ADAL" clId="{7B3DC166-71B5-486B-9834-38074F2BBE65}" dt="2025-11-18T19:08:44.786" v="10" actId="20577"/>
+        <pc:sldMkLst>
+          <pc:docMk/>
+          <pc:sldMk cId="2899031744" sldId="262"/>
+        </pc:sldMkLst>
+        <pc:spChg chg="mod">
+          <ac:chgData name="Licon, Ana Laura" userId="cd5c2778-d82d-4d36-9d52-40772a6c9161" providerId="ADAL" clId="{7B3DC166-71B5-486B-9834-38074F2BBE65}" dt="2025-11-18T19:08:44.786" v="10" actId="20577"/>
+          <ac:spMkLst>
+            <pc:docMk/>
+            <pc:sldMk cId="2899031744" sldId="262"/>
+            <ac:spMk id="2" creationId="{981FE52F-24A9-E406-60D9-204CB41F2C2F}"/>
+          </ac:spMkLst>
+        </pc:spChg>
+      </pc:sldChg>
+      <pc:sldChg chg="modSp mod">
+        <pc:chgData name="Licon, Ana Laura" userId="cd5c2778-d82d-4d36-9d52-40772a6c9161" providerId="ADAL" clId="{7B3DC166-71B5-486B-9834-38074F2BBE65}" dt="2025-11-18T19:09:25.460" v="17" actId="20577"/>
+        <pc:sldMkLst>
+          <pc:docMk/>
+          <pc:sldMk cId="2924031880" sldId="264"/>
+        </pc:sldMkLst>
+        <pc:spChg chg="mod">
+          <ac:chgData name="Licon, Ana Laura" userId="cd5c2778-d82d-4d36-9d52-40772a6c9161" providerId="ADAL" clId="{7B3DC166-71B5-486B-9834-38074F2BBE65}" dt="2025-11-18T19:09:25.460" v="17" actId="20577"/>
+          <ac:spMkLst>
+            <pc:docMk/>
+            <pc:sldMk cId="2924031880" sldId="264"/>
+            <ac:spMk id="2" creationId="{0E7113B2-A808-B641-796C-17E68BAC7A86}"/>
+          </ac:spMkLst>
+        </pc:spChg>
+      </pc:sldChg>
+      <pc:sldChg chg="modSp mod">
+        <pc:chgData name="Licon, Ana Laura" userId="cd5c2778-d82d-4d36-9d52-40772a6c9161" providerId="ADAL" clId="{7B3DC166-71B5-486B-9834-38074F2BBE65}" dt="2025-11-18T19:08:38.407" v="0" actId="20577"/>
+        <pc:sldMkLst>
+          <pc:docMk/>
+          <pc:sldMk cId="1558743291" sldId="266"/>
+        </pc:sldMkLst>
+        <pc:spChg chg="mod">
+          <ac:chgData name="Licon, Ana Laura" userId="cd5c2778-d82d-4d36-9d52-40772a6c9161" providerId="ADAL" clId="{7B3DC166-71B5-486B-9834-38074F2BBE65}" dt="2025-11-18T19:08:38.407" v="0" actId="20577"/>
+          <ac:spMkLst>
+            <pc:docMk/>
+            <pc:sldMk cId="1558743291" sldId="266"/>
+            <ac:spMk id="2" creationId="{E7DB3076-1C04-4477-55D8-F1C8F69C8BE9}"/>
+          </ac:spMkLst>
+        </pc:spChg>
+      </pc:sldChg>
+    </pc:docChg>
+  </pc:docChgLst>
   <pc:docChgLst>
     <pc:chgData name="Marjorie Biel" userId="1754441059_tp_dropbox_plus" providerId="OAuth2" clId="{DCB07449-C7DF-4DB7-B43A-320A2FCCA54F}"/>
     <pc:docChg chg="modSld">
@@ -3369,10 +3428,10 @@
           <c:layoutTarget val="inner"/>
           <c:xMode val="edge"/>
           <c:yMode val="edge"/>
-          <c:x val="8.924757471614389E-2"/>
-          <c:y val="4.7798556430446192E-2"/>
-          <c:w val="0.89853021272893374"/>
-          <c:h val="0.54443788276465443"/>
+          <c:x val="0.11506027996500437"/>
+          <c:y val="5.457633420822397E-2"/>
+          <c:w val="0.87271749781277341"/>
+          <c:h val="0.58004461942257213"/>
         </c:manualLayout>
       </c:layout>
       <c:lineChart>
@@ -3484,7 +3543,7 @@
           <c:smooth val="0"/>
           <c:extLst>
             <c:ext xmlns:c16="http://schemas.microsoft.com/office/drawing/2014/chart" uri="{C3380CC4-5D6E-409C-BE32-E72D297353CC}">
-              <c16:uniqueId val="{00000000-7E12-43A2-B958-1C7081544E01}"/>
+              <c16:uniqueId val="{00000000-2906-41F3-947A-594F7CC32F6B}"/>
             </c:ext>
           </c:extLst>
         </c:ser>
@@ -3594,7 +3653,7 @@
           <c:smooth val="0"/>
           <c:extLst>
             <c:ext xmlns:c16="http://schemas.microsoft.com/office/drawing/2014/chart" uri="{C3380CC4-5D6E-409C-BE32-E72D297353CC}">
-              <c16:uniqueId val="{00000001-7E12-43A2-B958-1C7081544E01}"/>
+              <c16:uniqueId val="{00000001-2906-41F3-947A-594F7CC32F6B}"/>
             </c:ext>
           </c:extLst>
         </c:ser>
@@ -3607,7 +3666,7 @@
               <c:strCache>
                 <c:ptCount val="1"/>
                 <c:pt idx="0">
-                  <c:v>Asian American/Pacific Islander</c:v>
+                  <c:v>Asian/Pacific Islander</c:v>
                 </c:pt>
               </c:strCache>
             </c:strRef>
@@ -3704,7 +3763,7 @@
           <c:smooth val="0"/>
           <c:extLst>
             <c:ext xmlns:c16="http://schemas.microsoft.com/office/drawing/2014/chart" uri="{C3380CC4-5D6E-409C-BE32-E72D297353CC}">
-              <c16:uniqueId val="{00000002-7E12-43A2-B958-1C7081544E01}"/>
+              <c16:uniqueId val="{00000002-2906-41F3-947A-594F7CC32F6B}"/>
             </c:ext>
           </c:extLst>
         </c:ser>
@@ -3717,7 +3776,7 @@
               <c:strCache>
                 <c:ptCount val="1"/>
                 <c:pt idx="0">
-                  <c:v>Native American/Alaska Native</c:v>
+                  <c:v>American Indian/Alaska Native</c:v>
                 </c:pt>
               </c:strCache>
             </c:strRef>
@@ -3814,7 +3873,7 @@
           <c:smooth val="0"/>
           <c:extLst>
             <c:ext xmlns:c16="http://schemas.microsoft.com/office/drawing/2014/chart" uri="{C3380CC4-5D6E-409C-BE32-E72D297353CC}">
-              <c16:uniqueId val="{00000003-7E12-43A2-B958-1C7081544E01}"/>
+              <c16:uniqueId val="{00000003-2906-41F3-947A-594F7CC32F6B}"/>
             </c:ext>
           </c:extLst>
         </c:ser>
@@ -3924,7 +3983,7 @@
           <c:smooth val="0"/>
           <c:extLst>
             <c:ext xmlns:c16="http://schemas.microsoft.com/office/drawing/2014/chart" uri="{C3380CC4-5D6E-409C-BE32-E72D297353CC}">
-              <c16:uniqueId val="{00000004-7E12-43A2-B958-1C7081544E01}"/>
+              <c16:uniqueId val="{00000004-2906-41F3-947A-594F7CC32F6B}"/>
             </c:ext>
           </c:extLst>
         </c:ser>
@@ -4040,7 +4099,7 @@
           <c:smooth val="0"/>
           <c:extLst>
             <c:ext xmlns:c16="http://schemas.microsoft.com/office/drawing/2014/chart" uri="{C3380CC4-5D6E-409C-BE32-E72D297353CC}">
-              <c16:uniqueId val="{00000005-7E12-43A2-B958-1C7081544E01}"/>
+              <c16:uniqueId val="{00000005-2906-41F3-947A-594F7CC32F6B}"/>
             </c:ext>
           </c:extLst>
         </c:ser>
@@ -4156,7 +4215,7 @@
           <c:smooth val="0"/>
           <c:extLst>
             <c:ext xmlns:c16="http://schemas.microsoft.com/office/drawing/2014/chart" uri="{C3380CC4-5D6E-409C-BE32-E72D297353CC}">
-              <c16:uniqueId val="{00000006-7E12-43A2-B958-1C7081544E01}"/>
+              <c16:uniqueId val="{00000006-2906-41F3-947A-594F7CC32F6B}"/>
             </c:ext>
           </c:extLst>
         </c:ser>
@@ -4267,7 +4326,7 @@
           <c:smooth val="0"/>
           <c:extLst>
             <c:ext xmlns:c16="http://schemas.microsoft.com/office/drawing/2014/chart" uri="{C3380CC4-5D6E-409C-BE32-E72D297353CC}">
-              <c16:uniqueId val="{00000007-7E12-43A2-B958-1C7081544E01}"/>
+              <c16:uniqueId val="{00000007-2906-41F3-947A-594F7CC32F6B}"/>
             </c:ext>
           </c:extLst>
         </c:ser>
@@ -4370,20 +4429,9 @@
                   </a:defRPr>
                 </a:pPr>
                 <a:r>
-                  <a:rPr lang="en-US" sz="2000" b="0" i="0" baseline="0" dirty="0" err="1">
-                    <a:effectLst/>
-                  </a:rPr>
-                  <a:t>ACEi</a:t>
+                  <a:rPr lang="en-US"/>
+                  <a:t>ACEi/ARB use (%)</a:t>
                 </a:r>
-                <a:r>
-                  <a:rPr lang="en-US" sz="2000" b="0" i="0" baseline="0" dirty="0">
-                    <a:effectLst/>
-                  </a:rPr>
-                  <a:t>/ARB use (%)</a:t>
-                </a:r>
-                <a:endParaRPr lang="en-US" sz="2000" dirty="0">
-                  <a:effectLst/>
-                </a:endParaRPr>
               </a:p>
             </c:rich>
           </c:tx>
@@ -4445,6 +4493,7 @@
         <c:crossAx val="1024696704"/>
         <c:crosses val="autoZero"/>
         <c:crossBetween val="between"/>
+        <c:majorUnit val="20"/>
       </c:valAx>
       <c:spPr>
         <a:noFill/>
@@ -4460,10 +4509,10 @@
         <c:manualLayout>
           <c:xMode val="edge"/>
           <c:yMode val="edge"/>
-          <c:x val="9.660542432195975E-4"/>
-          <c:y val="0.73469947506561695"/>
-          <c:w val="0.99695678040244973"/>
-          <c:h val="0.19863385826771654"/>
+          <c:x val="1.0421697287839022E-2"/>
+          <c:y val="0.76247725284339463"/>
+          <c:w val="0.98582327209098863"/>
+          <c:h val="0.22085608048993879"/>
         </c:manualLayout>
       </c:layout>
       <c:overlay val="0"/>
@@ -4546,10 +4595,10 @@
           <c:layoutTarget val="inner"/>
           <c:xMode val="edge"/>
           <c:yMode val="edge"/>
-          <c:x val="0.11562335958005249"/>
-          <c:y val="4.7798556430446192E-2"/>
-          <c:w val="0.87215441819772532"/>
-          <c:h val="0.57221566054243211"/>
+          <c:x val="0.11506027996500437"/>
+          <c:y val="5.457633420822397E-2"/>
+          <c:w val="0.87271749781277341"/>
+          <c:h val="0.59115573053368331"/>
         </c:manualLayout>
       </c:layout>
       <c:lineChart>
@@ -4661,7 +4710,7 @@
           <c:smooth val="0"/>
           <c:extLst>
             <c:ext xmlns:c16="http://schemas.microsoft.com/office/drawing/2014/chart" uri="{C3380CC4-5D6E-409C-BE32-E72D297353CC}">
-              <c16:uniqueId val="{00000000-8442-4D93-B195-0A5CC7CAFA48}"/>
+              <c16:uniqueId val="{00000000-E772-4FBF-BB09-8583C4201241}"/>
             </c:ext>
           </c:extLst>
         </c:ser>
@@ -4771,7 +4820,7 @@
           <c:smooth val="0"/>
           <c:extLst>
             <c:ext xmlns:c16="http://schemas.microsoft.com/office/drawing/2014/chart" uri="{C3380CC4-5D6E-409C-BE32-E72D297353CC}">
-              <c16:uniqueId val="{00000001-8442-4D93-B195-0A5CC7CAFA48}"/>
+              <c16:uniqueId val="{00000001-E772-4FBF-BB09-8583C4201241}"/>
             </c:ext>
           </c:extLst>
         </c:ser>
@@ -4784,7 +4833,7 @@
               <c:strCache>
                 <c:ptCount val="1"/>
                 <c:pt idx="0">
-                  <c:v>Asian American/Pacific Islander</c:v>
+                  <c:v>Asian/Pacific Islander</c:v>
                 </c:pt>
               </c:strCache>
             </c:strRef>
@@ -4881,7 +4930,7 @@
           <c:smooth val="0"/>
           <c:extLst>
             <c:ext xmlns:c16="http://schemas.microsoft.com/office/drawing/2014/chart" uri="{C3380CC4-5D6E-409C-BE32-E72D297353CC}">
-              <c16:uniqueId val="{00000002-8442-4D93-B195-0A5CC7CAFA48}"/>
+              <c16:uniqueId val="{00000002-E772-4FBF-BB09-8583C4201241}"/>
             </c:ext>
           </c:extLst>
         </c:ser>
@@ -4894,7 +4943,7 @@
               <c:strCache>
                 <c:ptCount val="1"/>
                 <c:pt idx="0">
-                  <c:v>Native American/Alaska Native</c:v>
+                  <c:v>American Indian/Alaska Native</c:v>
                 </c:pt>
               </c:strCache>
             </c:strRef>
@@ -4991,7 +5040,7 @@
           <c:smooth val="0"/>
           <c:extLst>
             <c:ext xmlns:c16="http://schemas.microsoft.com/office/drawing/2014/chart" uri="{C3380CC4-5D6E-409C-BE32-E72D297353CC}">
-              <c16:uniqueId val="{00000003-8442-4D93-B195-0A5CC7CAFA48}"/>
+              <c16:uniqueId val="{00000003-E772-4FBF-BB09-8583C4201241}"/>
             </c:ext>
           </c:extLst>
         </c:ser>
@@ -5101,7 +5150,7 @@
           <c:smooth val="0"/>
           <c:extLst>
             <c:ext xmlns:c16="http://schemas.microsoft.com/office/drawing/2014/chart" uri="{C3380CC4-5D6E-409C-BE32-E72D297353CC}">
-              <c16:uniqueId val="{00000004-8442-4D93-B195-0A5CC7CAFA48}"/>
+              <c16:uniqueId val="{00000004-E772-4FBF-BB09-8583C4201241}"/>
             </c:ext>
           </c:extLst>
         </c:ser>
@@ -5217,7 +5266,7 @@
           <c:smooth val="0"/>
           <c:extLst>
             <c:ext xmlns:c16="http://schemas.microsoft.com/office/drawing/2014/chart" uri="{C3380CC4-5D6E-409C-BE32-E72D297353CC}">
-              <c16:uniqueId val="{00000005-8442-4D93-B195-0A5CC7CAFA48}"/>
+              <c16:uniqueId val="{00000005-E772-4FBF-BB09-8583C4201241}"/>
             </c:ext>
           </c:extLst>
         </c:ser>
@@ -5333,7 +5382,7 @@
           <c:smooth val="0"/>
           <c:extLst>
             <c:ext xmlns:c16="http://schemas.microsoft.com/office/drawing/2014/chart" uri="{C3380CC4-5D6E-409C-BE32-E72D297353CC}">
-              <c16:uniqueId val="{00000006-8442-4D93-B195-0A5CC7CAFA48}"/>
+              <c16:uniqueId val="{00000006-E772-4FBF-BB09-8583C4201241}"/>
             </c:ext>
           </c:extLst>
         </c:ser>
@@ -5444,7 +5493,7 @@
           <c:smooth val="0"/>
           <c:extLst>
             <c:ext xmlns:c16="http://schemas.microsoft.com/office/drawing/2014/chart" uri="{C3380CC4-5D6E-409C-BE32-E72D297353CC}">
-              <c16:uniqueId val="{00000007-8442-4D93-B195-0A5CC7CAFA48}"/>
+              <c16:uniqueId val="{00000007-E772-4FBF-BB09-8583C4201241}"/>
             </c:ext>
           </c:extLst>
         </c:ser>
@@ -5537,7 +5586,7 @@
               <a:bodyPr rot="-5400000" spcFirstLastPara="1" vertOverflow="ellipsis" vert="horz" wrap="square" anchor="ctr" anchorCtr="1"/>
               <a:lstStyle/>
               <a:p>
-                <a:pPr algn="ctr" rtl="0">
+                <a:pPr>
                   <a:defRPr sz="2000" b="0" i="0" u="none" strike="noStrike" kern="1200" baseline="0">
                     <a:solidFill>
                       <a:schemeClr val="tx1"/>
@@ -5548,8 +5597,8 @@
                   </a:defRPr>
                 </a:pPr>
                 <a:r>
-                  <a:rPr lang="en-US" dirty="0"/>
-                  <a:t>ACEI/ARB use (%)</a:t>
+                  <a:rPr lang="en-US"/>
+                  <a:t>ACEi/ARB use (%)</a:t>
                 </a:r>
               </a:p>
             </c:rich>
@@ -5566,7 +5615,7 @@
             <a:bodyPr rot="-5400000" spcFirstLastPara="1" vertOverflow="ellipsis" vert="horz" wrap="square" anchor="ctr" anchorCtr="1"/>
             <a:lstStyle/>
             <a:p>
-              <a:pPr algn="ctr" rtl="0">
+              <a:pPr>
                 <a:defRPr sz="2000" b="0" i="0" u="none" strike="noStrike" kern="1200" baseline="0">
                   <a:solidFill>
                     <a:schemeClr val="tx1"/>
@@ -5587,9 +5636,7 @@
         <c:spPr>
           <a:noFill/>
           <a:ln>
-            <a:solidFill>
-              <a:schemeClr val="tx1"/>
-            </a:solidFill>
+            <a:noFill/>
             <a:prstDash val="sysDash"/>
           </a:ln>
           <a:effectLst/>
@@ -5614,7 +5661,6 @@
         <c:crossAx val="1024696704"/>
         <c:crosses val="autoZero"/>
         <c:crossBetween val="between"/>
-        <c:majorUnit val="20"/>
       </c:valAx>
       <c:spPr>
         <a:noFill/>
@@ -5630,10 +5676,10 @@
         <c:manualLayout>
           <c:xMode val="edge"/>
           <c:yMode val="edge"/>
-          <c:x val="3.3107611548556467E-3"/>
-          <c:y val="0.74115791776027984"/>
-          <c:w val="0.99668923884514438"/>
-          <c:h val="0.20050874890638667"/>
+          <c:x val="7.0883639545056883E-3"/>
+          <c:y val="0.75136614173228344"/>
+          <c:w val="0.98804549431321087"/>
+          <c:h val="0.23196719160104987"/>
         </c:manualLayout>
       </c:layout>
       <c:overlay val="0"/>
@@ -5723,7 +5769,7 @@
               <c:strCache>
                 <c:ptCount val="1"/>
                 <c:pt idx="0">
-                  <c:v>Stage 1</c:v>
+                  <c:v>CKD Stage 1</c:v>
                 </c:pt>
               </c:strCache>
             </c:strRef>
@@ -5754,7 +5800,7 @@
           </c:marker>
           <c:cat>
             <c:strRef>
-              <c:f>'ACEI-ARB DM-CKD by CKD Stage'!$C$60:$J$60</c:f>
+              <c:f>'ACEI-ARB DM-CKD by CKD Stage'!$D$1:$K$1</c:f>
               <c:strCache>
                 <c:ptCount val="8"/>
                 <c:pt idx="0">
@@ -5820,7 +5866,7 @@
           <c:smooth val="0"/>
           <c:extLst>
             <c:ext xmlns:c16="http://schemas.microsoft.com/office/drawing/2014/chart" uri="{C3380CC4-5D6E-409C-BE32-E72D297353CC}">
-              <c16:uniqueId val="{00000001-A5AB-489D-8693-4F1E1C260284}"/>
+              <c16:uniqueId val="{00000000-4F65-4883-8DAB-9C9EE54AFBAB}"/>
             </c:ext>
           </c:extLst>
         </c:ser>
@@ -5833,7 +5879,7 @@
               <c:strCache>
                 <c:ptCount val="1"/>
                 <c:pt idx="0">
-                  <c:v>Stage 2</c:v>
+                  <c:v>CKD Stage 2</c:v>
                 </c:pt>
               </c:strCache>
             </c:strRef>
@@ -5864,7 +5910,7 @@
           </c:marker>
           <c:cat>
             <c:strRef>
-              <c:f>'ACEI-ARB DM-CKD by CKD Stage'!$C$60:$J$60</c:f>
+              <c:f>'ACEI-ARB DM-CKD by CKD Stage'!$D$1:$K$1</c:f>
               <c:strCache>
                 <c:ptCount val="8"/>
                 <c:pt idx="0">
@@ -5930,7 +5976,7 @@
           <c:smooth val="0"/>
           <c:extLst>
             <c:ext xmlns:c16="http://schemas.microsoft.com/office/drawing/2014/chart" uri="{C3380CC4-5D6E-409C-BE32-E72D297353CC}">
-              <c16:uniqueId val="{00000002-A5AB-489D-8693-4F1E1C260284}"/>
+              <c16:uniqueId val="{00000001-4F65-4883-8DAB-9C9EE54AFBAB}"/>
             </c:ext>
           </c:extLst>
         </c:ser>
@@ -5943,7 +5989,7 @@
               <c:strCache>
                 <c:ptCount val="1"/>
                 <c:pt idx="0">
-                  <c:v>Stage 3</c:v>
+                  <c:v>CKD Stage 3</c:v>
                 </c:pt>
               </c:strCache>
             </c:strRef>
@@ -5974,7 +6020,7 @@
           </c:marker>
           <c:cat>
             <c:strRef>
-              <c:f>'ACEI-ARB DM-CKD by CKD Stage'!$C$60:$J$60</c:f>
+              <c:f>'ACEI-ARB DM-CKD by CKD Stage'!$D$1:$K$1</c:f>
               <c:strCache>
                 <c:ptCount val="8"/>
                 <c:pt idx="0">
@@ -6040,7 +6086,7 @@
           <c:smooth val="0"/>
           <c:extLst>
             <c:ext xmlns:c16="http://schemas.microsoft.com/office/drawing/2014/chart" uri="{C3380CC4-5D6E-409C-BE32-E72D297353CC}">
-              <c16:uniqueId val="{00000003-A5AB-489D-8693-4F1E1C260284}"/>
+              <c16:uniqueId val="{00000002-4F65-4883-8DAB-9C9EE54AFBAB}"/>
             </c:ext>
           </c:extLst>
         </c:ser>
@@ -6053,7 +6099,7 @@
               <c:strCache>
                 <c:ptCount val="1"/>
                 <c:pt idx="0">
-                  <c:v>Stage 4</c:v>
+                  <c:v>CKD Stage 4</c:v>
                 </c:pt>
               </c:strCache>
             </c:strRef>
@@ -6084,7 +6130,7 @@
           </c:marker>
           <c:cat>
             <c:strRef>
-              <c:f>'ACEI-ARB DM-CKD by CKD Stage'!$C$60:$J$60</c:f>
+              <c:f>'ACEI-ARB DM-CKD by CKD Stage'!$D$1:$K$1</c:f>
               <c:strCache>
                 <c:ptCount val="8"/>
                 <c:pt idx="0">
@@ -6150,7 +6196,7 @@
           <c:smooth val="0"/>
           <c:extLst>
             <c:ext xmlns:c16="http://schemas.microsoft.com/office/drawing/2014/chart" uri="{C3380CC4-5D6E-409C-BE32-E72D297353CC}">
-              <c16:uniqueId val="{00000004-A5AB-489D-8693-4F1E1C260284}"/>
+              <c16:uniqueId val="{00000003-4F65-4883-8DAB-9C9EE54AFBAB}"/>
             </c:ext>
           </c:extLst>
         </c:ser>
@@ -6163,7 +6209,7 @@
               <c:strCache>
                 <c:ptCount val="1"/>
                 <c:pt idx="0">
-                  <c:v>Stage 5</c:v>
+                  <c:v>CKD Stage 5</c:v>
                 </c:pt>
               </c:strCache>
             </c:strRef>
@@ -6194,7 +6240,7 @@
           </c:marker>
           <c:cat>
             <c:strRef>
-              <c:f>'ACEI-ARB DM-CKD by CKD Stage'!$C$60:$J$60</c:f>
+              <c:f>'ACEI-ARB DM-CKD by CKD Stage'!$D$1:$K$1</c:f>
               <c:strCache>
                 <c:ptCount val="8"/>
                 <c:pt idx="0">
@@ -6260,7 +6306,7 @@
           <c:smooth val="0"/>
           <c:extLst>
             <c:ext xmlns:c16="http://schemas.microsoft.com/office/drawing/2014/chart" uri="{C3380CC4-5D6E-409C-BE32-E72D297353CC}">
-              <c16:uniqueId val="{00000005-A5AB-489D-8693-4F1E1C260284}"/>
+              <c16:uniqueId val="{00000004-4F65-4883-8DAB-9C9EE54AFBAB}"/>
             </c:ext>
           </c:extLst>
         </c:ser>
@@ -6310,7 +6356,7 @@
           </c:marker>
           <c:cat>
             <c:strRef>
-              <c:f>'ACEI-ARB DM-CKD by CKD Stage'!$C$60:$J$60</c:f>
+              <c:f>'ACEI-ARB DM-CKD by CKD Stage'!$D$1:$K$1</c:f>
               <c:strCache>
                 <c:ptCount val="8"/>
                 <c:pt idx="0">
@@ -6376,7 +6422,7 @@
           <c:smooth val="0"/>
           <c:extLst>
             <c:ext xmlns:c16="http://schemas.microsoft.com/office/drawing/2014/chart" uri="{C3380CC4-5D6E-409C-BE32-E72D297353CC}">
-              <c16:uniqueId val="{00000006-A5AB-489D-8693-4F1E1C260284}"/>
+              <c16:uniqueId val="{00000005-4F65-4883-8DAB-9C9EE54AFBAB}"/>
             </c:ext>
           </c:extLst>
         </c:ser>
@@ -6426,7 +6472,7 @@
           </c:marker>
           <c:cat>
             <c:strRef>
-              <c:f>'ACEI-ARB DM-CKD by CKD Stage'!$C$60:$J$60</c:f>
+              <c:f>'ACEI-ARB DM-CKD by CKD Stage'!$D$1:$K$1</c:f>
               <c:strCache>
                 <c:ptCount val="8"/>
                 <c:pt idx="0">
@@ -6492,7 +6538,7 @@
           <c:smooth val="0"/>
           <c:extLst>
             <c:ext xmlns:c16="http://schemas.microsoft.com/office/drawing/2014/chart" uri="{C3380CC4-5D6E-409C-BE32-E72D297353CC}">
-              <c16:uniqueId val="{00000007-A5AB-489D-8693-4F1E1C260284}"/>
+              <c16:uniqueId val="{00000006-4F65-4883-8DAB-9C9EE54AFBAB}"/>
             </c:ext>
           </c:extLst>
         </c:ser>
@@ -6537,7 +6583,7 @@
           </c:marker>
           <c:cat>
             <c:strRef>
-              <c:f>'ACEI-ARB DM-CKD by CKD Stage'!$C$60:$J$60</c:f>
+              <c:f>'ACEI-ARB DM-CKD by CKD Stage'!$D$1:$K$1</c:f>
               <c:strCache>
                 <c:ptCount val="8"/>
                 <c:pt idx="0">
@@ -6603,7 +6649,7 @@
           <c:smooth val="0"/>
           <c:extLst>
             <c:ext xmlns:c16="http://schemas.microsoft.com/office/drawing/2014/chart" uri="{C3380CC4-5D6E-409C-BE32-E72D297353CC}">
-              <c16:uniqueId val="{00000000-A5AB-489D-8693-4F1E1C260284}"/>
+              <c16:uniqueId val="{00000007-4F65-4883-8DAB-9C9EE54AFBAB}"/>
             </c:ext>
           </c:extLst>
         </c:ser>
@@ -6617,11 +6663,11 @@
         </c:dLbls>
         <c:marker val="1"/>
         <c:smooth val="0"/>
-        <c:axId val="710794735"/>
-        <c:axId val="710795567"/>
+        <c:axId val="421459343"/>
+        <c:axId val="421457679"/>
       </c:lineChart>
       <c:catAx>
-        <c:axId val="710794735"/>
+        <c:axId val="421459343"/>
         <c:scaling>
           <c:orientation val="minMax"/>
         </c:scaling>
@@ -6661,7 +6707,7 @@
             <a:endParaRPr lang="en-US"/>
           </a:p>
         </c:txPr>
-        <c:crossAx val="710795567"/>
+        <c:crossAx val="421457679"/>
         <c:crosses val="autoZero"/>
         <c:auto val="1"/>
         <c:lblAlgn val="ctr"/>
@@ -6669,7 +6715,7 @@
         <c:noMultiLvlLbl val="0"/>
       </c:catAx>
       <c:valAx>
-        <c:axId val="710795567"/>
+        <c:axId val="421457679"/>
         <c:scaling>
           <c:orientation val="minMax"/>
         </c:scaling>
@@ -6706,12 +6752,8 @@
                   </a:defRPr>
                 </a:pPr>
                 <a:r>
-                  <a:rPr lang="en-US" dirty="0" err="1"/>
-                  <a:t>ACEi</a:t>
-                </a:r>
-                <a:r>
-                  <a:rPr lang="en-US" dirty="0"/>
-                  <a:t>/ARB use (%)</a:t>
+                  <a:rPr lang="en-US"/>
+                  <a:t>ACEi/ARB use (%)</a:t>
                 </a:r>
               </a:p>
             </c:rich>
@@ -6770,7 +6812,7 @@
             <a:endParaRPr lang="en-US"/>
           </a:p>
         </c:txPr>
-        <c:crossAx val="710794735"/>
+        <c:crossAx val="421459343"/>
         <c:crosses val="autoZero"/>
         <c:crossBetween val="between"/>
       </c:valAx>
@@ -6788,10 +6830,10 @@
         <c:manualLayout>
           <c:xMode val="edge"/>
           <c:yMode val="edge"/>
-          <c:x val="1.0552930883639532E-3"/>
+          <c:x val="1.5499737532808396E-2"/>
           <c:y val="0.79304418197725279"/>
-          <c:w val="0.99894470691163606"/>
-          <c:h val="0.1375113735783027"/>
+          <c:w val="0.97344496937882752"/>
+          <c:h val="0.19028915135608049"/>
         </c:manualLayout>
       </c:layout>
       <c:overlay val="0"/>
@@ -6874,17 +6916,7 @@
   <c:chart>
     <c:autoTitleDeleted val="1"/>
     <c:plotArea>
-      <c:layout>
-        <c:manualLayout>
-          <c:layoutTarget val="inner"/>
-          <c:xMode val="edge"/>
-          <c:yMode val="edge"/>
-          <c:x val="9.8751093613298341E-2"/>
-          <c:y val="4.7798556430446192E-2"/>
-          <c:w val="0.88902668416447939"/>
-          <c:h val="0.68392455098807314"/>
-        </c:manualLayout>
-      </c:layout>
+      <c:layout/>
       <c:lineChart>
         <c:grouping val="standard"/>
         <c:varyColors val="0"/>
@@ -6897,7 +6929,7 @@
               <c:strCache>
                 <c:ptCount val="1"/>
                 <c:pt idx="0">
-                  <c:v>Stage 1</c:v>
+                  <c:v>CKD Stage 1</c:v>
                 </c:pt>
               </c:strCache>
             </c:strRef>
@@ -6994,7 +7026,7 @@
           <c:smooth val="0"/>
           <c:extLst>
             <c:ext xmlns:c16="http://schemas.microsoft.com/office/drawing/2014/chart" uri="{C3380CC4-5D6E-409C-BE32-E72D297353CC}">
-              <c16:uniqueId val="{00000000-A2C5-4586-BEA3-6A93D70CF345}"/>
+              <c16:uniqueId val="{00000000-CF16-4A53-A1DB-E7919E9530D7}"/>
             </c:ext>
           </c:extLst>
         </c:ser>
@@ -7007,7 +7039,7 @@
               <c:strCache>
                 <c:ptCount val="1"/>
                 <c:pt idx="0">
-                  <c:v>Stage 2</c:v>
+                  <c:v>CKD Stage 2</c:v>
                 </c:pt>
               </c:strCache>
             </c:strRef>
@@ -7104,7 +7136,7 @@
           <c:smooth val="0"/>
           <c:extLst>
             <c:ext xmlns:c16="http://schemas.microsoft.com/office/drawing/2014/chart" uri="{C3380CC4-5D6E-409C-BE32-E72D297353CC}">
-              <c16:uniqueId val="{00000001-A2C5-4586-BEA3-6A93D70CF345}"/>
+              <c16:uniqueId val="{00000001-CF16-4A53-A1DB-E7919E9530D7}"/>
             </c:ext>
           </c:extLst>
         </c:ser>
@@ -7117,7 +7149,7 @@
               <c:strCache>
                 <c:ptCount val="1"/>
                 <c:pt idx="0">
-                  <c:v>Stage 3</c:v>
+                  <c:v>CKD Stage 3</c:v>
                 </c:pt>
               </c:strCache>
             </c:strRef>
@@ -7214,7 +7246,7 @@
           <c:smooth val="0"/>
           <c:extLst>
             <c:ext xmlns:c16="http://schemas.microsoft.com/office/drawing/2014/chart" uri="{C3380CC4-5D6E-409C-BE32-E72D297353CC}">
-              <c16:uniqueId val="{00000002-A2C5-4586-BEA3-6A93D70CF345}"/>
+              <c16:uniqueId val="{00000002-CF16-4A53-A1DB-E7919E9530D7}"/>
             </c:ext>
           </c:extLst>
         </c:ser>
@@ -7227,7 +7259,7 @@
               <c:strCache>
                 <c:ptCount val="1"/>
                 <c:pt idx="0">
-                  <c:v>Stage 4</c:v>
+                  <c:v>CKD Stage 4</c:v>
                 </c:pt>
               </c:strCache>
             </c:strRef>
@@ -7324,7 +7356,7 @@
           <c:smooth val="0"/>
           <c:extLst>
             <c:ext xmlns:c16="http://schemas.microsoft.com/office/drawing/2014/chart" uri="{C3380CC4-5D6E-409C-BE32-E72D297353CC}">
-              <c16:uniqueId val="{00000003-A2C5-4586-BEA3-6A93D70CF345}"/>
+              <c16:uniqueId val="{00000003-CF16-4A53-A1DB-E7919E9530D7}"/>
             </c:ext>
           </c:extLst>
         </c:ser>
@@ -7337,7 +7369,7 @@
               <c:strCache>
                 <c:ptCount val="1"/>
                 <c:pt idx="0">
-                  <c:v>Stage 5</c:v>
+                  <c:v>CKD Stage 5</c:v>
                 </c:pt>
               </c:strCache>
             </c:strRef>
@@ -7434,7 +7466,7 @@
           <c:smooth val="0"/>
           <c:extLst>
             <c:ext xmlns:c16="http://schemas.microsoft.com/office/drawing/2014/chart" uri="{C3380CC4-5D6E-409C-BE32-E72D297353CC}">
-              <c16:uniqueId val="{00000004-A2C5-4586-BEA3-6A93D70CF345}"/>
+              <c16:uniqueId val="{00000004-CF16-4A53-A1DB-E7919E9530D7}"/>
             </c:ext>
           </c:extLst>
         </c:ser>
@@ -7550,7 +7582,7 @@
           <c:smooth val="0"/>
           <c:extLst>
             <c:ext xmlns:c16="http://schemas.microsoft.com/office/drawing/2014/chart" uri="{C3380CC4-5D6E-409C-BE32-E72D297353CC}">
-              <c16:uniqueId val="{00000005-A2C5-4586-BEA3-6A93D70CF345}"/>
+              <c16:uniqueId val="{00000005-CF16-4A53-A1DB-E7919E9530D7}"/>
             </c:ext>
           </c:extLst>
         </c:ser>
@@ -7666,7 +7698,7 @@
           <c:smooth val="0"/>
           <c:extLst>
             <c:ext xmlns:c16="http://schemas.microsoft.com/office/drawing/2014/chart" uri="{C3380CC4-5D6E-409C-BE32-E72D297353CC}">
-              <c16:uniqueId val="{00000006-A2C5-4586-BEA3-6A93D70CF345}"/>
+              <c16:uniqueId val="{00000006-CF16-4A53-A1DB-E7919E9530D7}"/>
             </c:ext>
           </c:extLst>
         </c:ser>
@@ -7777,7 +7809,7 @@
           <c:smooth val="0"/>
           <c:extLst>
             <c:ext xmlns:c16="http://schemas.microsoft.com/office/drawing/2014/chart" uri="{C3380CC4-5D6E-409C-BE32-E72D297353CC}">
-              <c16:uniqueId val="{00000007-A2C5-4586-BEA3-6A93D70CF345}"/>
+              <c16:uniqueId val="{00000007-CF16-4A53-A1DB-E7919E9530D7}"/>
             </c:ext>
           </c:extLst>
         </c:ser>
@@ -7846,7 +7878,6 @@
         <c:axId val="681524927"/>
         <c:scaling>
           <c:orientation val="minMax"/>
-          <c:max val="100"/>
         </c:scaling>
         <c:delete val="0"/>
         <c:axPos val="l"/>
@@ -7944,7 +7975,6 @@
         <c:crossAx val="681522015"/>
         <c:crosses val="autoZero"/>
         <c:crossBetween val="between"/>
-        <c:majorUnit val="20"/>
       </c:valAx>
       <c:spPr>
         <a:noFill/>
@@ -7956,34 +7986,14 @@
     </c:plotArea>
     <c:legend>
       <c:legendPos val="b"/>
-      <c:legendEntry>
-        <c:idx val="6"/>
-        <c:txPr>
-          <a:bodyPr rot="0" spcFirstLastPara="1" vertOverflow="ellipsis" vert="horz" wrap="square" anchor="ctr" anchorCtr="1"/>
-          <a:lstStyle/>
-          <a:p>
-            <a:pPr>
-              <a:defRPr sz="2400" b="0" i="0" u="none" strike="noStrike" kern="1200" baseline="0">
-                <a:solidFill>
-                  <a:schemeClr val="tx1"/>
-                </a:solidFill>
-                <a:latin typeface="+mn-lt"/>
-                <a:ea typeface="+mn-ea"/>
-                <a:cs typeface="+mn-cs"/>
-              </a:defRPr>
-            </a:pPr>
-            <a:endParaRPr lang="en-US"/>
-          </a:p>
-        </c:txPr>
-      </c:legendEntry>
       <c:layout>
         <c:manualLayout>
           <c:xMode val="edge"/>
           <c:yMode val="edge"/>
-          <c:x val="3.3333333333333335E-3"/>
-          <c:y val="0.77659196692547661"/>
-          <c:w val="0.9966666666666667"/>
-          <c:h val="0.2234080330745235"/>
+          <c:x val="1.5499737532808396E-2"/>
+          <c:y val="0.79304418197725279"/>
+          <c:w val="0.97900052493438305"/>
+          <c:h val="0.19028915135608049"/>
         </c:manualLayout>
       </c:layout>
       <c:overlay val="0"/>
@@ -13019,7 +13029,7 @@
           <a:p>
             <a:fld id="{0AF73B43-6A56-473B-AE2D-AB20CDBDB644}" type="datetimeFigureOut">
               <a:rPr lang="en-US" smtClean="0"/>
-              <a:t>10/21/2025</a:t>
+              <a:t>11/18/2025</a:t>
             </a:fld>
             <a:endParaRPr lang="en-US"/>
           </a:p>
@@ -13812,7 +13822,7 @@
           <a:p>
             <a:fld id="{740713D3-AB50-4A09-8DB2-7F26C27F2607}" type="datetimeFigureOut">
               <a:rPr lang="en-US" smtClean="0"/>
-              <a:t>10/21/2025</a:t>
+              <a:t>11/18/2025</a:t>
             </a:fld>
             <a:endParaRPr lang="en-US"/>
           </a:p>
@@ -14020,7 +14030,7 @@
           <a:p>
             <a:fld id="{740713D3-AB50-4A09-8DB2-7F26C27F2607}" type="datetimeFigureOut">
               <a:rPr lang="en-US" smtClean="0"/>
-              <a:t>10/21/2025</a:t>
+              <a:t>11/18/2025</a:t>
             </a:fld>
             <a:endParaRPr lang="en-US"/>
           </a:p>
@@ -14229,7 +14239,7 @@
           <a:p>
             <a:fld id="{740713D3-AB50-4A09-8DB2-7F26C27F2607}" type="datetimeFigureOut">
               <a:rPr lang="en-US" smtClean="0"/>
-              <a:t>10/21/2025</a:t>
+              <a:t>11/18/2025</a:t>
             </a:fld>
             <a:endParaRPr lang="en-US"/>
           </a:p>
@@ -14544,7 +14554,7 @@
           <a:p>
             <a:fld id="{740713D3-AB50-4A09-8DB2-7F26C27F2607}" type="datetimeFigureOut">
               <a:rPr lang="en-US" smtClean="0"/>
-              <a:t>10/21/2025</a:t>
+              <a:t>11/18/2025</a:t>
             </a:fld>
             <a:endParaRPr lang="en-US"/>
           </a:p>
@@ -14850,7 +14860,7 @@
           <a:p>
             <a:fld id="{740713D3-AB50-4A09-8DB2-7F26C27F2607}" type="datetimeFigureOut">
               <a:rPr lang="en-US" smtClean="0"/>
-              <a:t>10/21/2025</a:t>
+              <a:t>11/18/2025</a:t>
             </a:fld>
             <a:endParaRPr lang="en-US"/>
           </a:p>
@@ -15298,7 +15308,7 @@
           <a:p>
             <a:fld id="{740713D3-AB50-4A09-8DB2-7F26C27F2607}" type="datetimeFigureOut">
               <a:rPr lang="en-US" smtClean="0"/>
-              <a:t>10/21/2025</a:t>
+              <a:t>11/18/2025</a:t>
             </a:fld>
             <a:endParaRPr lang="en-US"/>
           </a:p>
@@ -15480,7 +15490,7 @@
           <a:p>
             <a:fld id="{740713D3-AB50-4A09-8DB2-7F26C27F2607}" type="datetimeFigureOut">
               <a:rPr lang="en-US" smtClean="0"/>
-              <a:t>10/21/2025</a:t>
+              <a:t>11/18/2025</a:t>
             </a:fld>
             <a:endParaRPr lang="en-US"/>
           </a:p>
@@ -15629,7 +15639,7 @@
           <a:p>
             <a:fld id="{740713D3-AB50-4A09-8DB2-7F26C27F2607}" type="datetimeFigureOut">
               <a:rPr lang="en-US" smtClean="0"/>
-              <a:t>10/21/2025</a:t>
+              <a:t>11/18/2025</a:t>
             </a:fld>
             <a:endParaRPr lang="en-US"/>
           </a:p>
@@ -15977,7 +15987,7 @@
           <a:p>
             <a:fld id="{740713D3-AB50-4A09-8DB2-7F26C27F2607}" type="datetimeFigureOut">
               <a:rPr lang="en-US" smtClean="0"/>
-              <a:t>10/21/2025</a:t>
+              <a:t>11/18/2025</a:t>
             </a:fld>
             <a:endParaRPr lang="en-US"/>
           </a:p>
@@ -16305,7 +16315,7 @@
           <a:p>
             <a:fld id="{740713D3-AB50-4A09-8DB2-7F26C27F2607}" type="datetimeFigureOut">
               <a:rPr lang="en-US" smtClean="0"/>
-              <a:t>10/21/2025</a:t>
+              <a:t>11/18/2025</a:t>
             </a:fld>
             <a:endParaRPr lang="en-US"/>
           </a:p>
@@ -16583,7 +16593,7 @@
           <a:p>
             <a:fld id="{740713D3-AB50-4A09-8DB2-7F26C27F2607}" type="datetimeFigureOut">
               <a:rPr lang="en-US" smtClean="0"/>
-              <a:t>10/21/2025</a:t>
+              <a:t>11/18/2025</a:t>
             </a:fld>
             <a:endParaRPr lang="en-US"/>
           </a:p>
@@ -17018,8 +17028,8 @@
         </p:nvSpPr>
         <p:spPr/>
         <p:txBody>
-          <a:bodyPr>
-            <a:normAutofit fontScale="90000"/>
+          <a:bodyPr anchor="ctr">
+            <a:normAutofit/>
           </a:bodyPr>
           <a:lstStyle/>
           <a:p>
@@ -17029,7 +17039,7 @@
             </a:r>
             <a:r>
               <a:rPr lang="en-US" dirty="0"/>
-              <a:t> or ARB use in Diabetes Mellitus (Types 1 and 2 DM) With Chronic Kidney Disease in the Military Health System </a:t>
+              <a:t>/ARB use among Adults with Diabetes Mellitus with CKD in the Military Health System</a:t>
             </a:r>
           </a:p>
         </p:txBody>
@@ -17165,7 +17175,7 @@
       </p:sp>
       <p:graphicFrame>
         <p:nvGraphicFramePr>
-          <p:cNvPr id="6" name="Chart 5">
+          <p:cNvPr id="4" name="Chart 3">
             <a:extLst>
               <a:ext uri="{FF2B5EF4-FFF2-40B4-BE49-F238E27FC236}">
                 <a16:creationId xmlns:a16="http://schemas.microsoft.com/office/drawing/2014/main" id="{6B68B2F7-0204-4B68-B563-9BAC1C265113}"/>
@@ -17178,14 +17188,14 @@
           <p:nvPr>
             <p:extLst>
               <p:ext uri="{D42A27DB-BD31-4B8C-83A1-F6EECF244321}">
-                <p14:modId xmlns:p14="http://schemas.microsoft.com/office/powerpoint/2010/main" val="1829083836"/>
+                <p14:modId xmlns:p14="http://schemas.microsoft.com/office/powerpoint/2010/main" val="1632729165"/>
               </p:ext>
             </p:extLst>
           </p:nvPr>
         </p:nvGraphicFramePr>
         <p:xfrm>
-          <a:off x="266700" y="1587500"/>
-          <a:ext cx="11734800" cy="4677437"/>
+          <a:off x="381000" y="1692937"/>
+          <a:ext cx="11430000" cy="4572000"/>
         </p:xfrm>
         <a:graphic>
           <a:graphicData uri="http://schemas.openxmlformats.org/drawingml/2006/chart">
@@ -17677,7 +17687,14 @@
             </a:r>
             <a:r>
               <a:rPr lang="en-US" dirty="0"/>
-              <a:t>/ARB use in DM with CKD by Sex, Age Standardized</a:t>
+              <a:t>/ARB use in DM with CKD by Sex, </a:t>
+            </a:r>
+            <a:br>
+              <a:rPr lang="en-US" dirty="0"/>
+            </a:br>
+            <a:r>
+              <a:rPr lang="en-US" dirty="0"/>
+              <a:t>Age Standardized</a:t>
             </a:r>
           </a:p>
         </p:txBody>
@@ -17782,14 +17799,14 @@
             </a:r>
             <a:r>
               <a:rPr lang="en-US" dirty="0"/>
-              <a:t>/ARB use in DM with CKD by Race, Crude</a:t>
+              <a:t>/ARB use in DM with CKD by Race/Ethnicity, Crude</a:t>
             </a:r>
           </a:p>
         </p:txBody>
       </p:sp>
       <p:graphicFrame>
         <p:nvGraphicFramePr>
-          <p:cNvPr id="6" name="Chart 5">
+          <p:cNvPr id="7" name="Chart 6">
             <a:extLst>
               <a:ext uri="{FF2B5EF4-FFF2-40B4-BE49-F238E27FC236}">
                 <a16:creationId xmlns:a16="http://schemas.microsoft.com/office/drawing/2014/main" id="{9E500B5D-E27D-AEB4-3100-897AF08653B2}"/>
@@ -17802,14 +17819,14 @@
           <p:nvPr>
             <p:extLst>
               <p:ext uri="{D42A27DB-BD31-4B8C-83A1-F6EECF244321}">
-                <p14:modId xmlns:p14="http://schemas.microsoft.com/office/powerpoint/2010/main" val="401832339"/>
+                <p14:modId xmlns:p14="http://schemas.microsoft.com/office/powerpoint/2010/main" val="2276205418"/>
               </p:ext>
             </p:extLst>
           </p:nvPr>
         </p:nvGraphicFramePr>
         <p:xfrm>
-          <a:off x="317500" y="1692937"/>
-          <a:ext cx="11493500" cy="4572000"/>
+          <a:off x="381000" y="1692937"/>
+          <a:ext cx="11430000" cy="4572000"/>
         </p:xfrm>
         <a:graphic>
           <a:graphicData uri="http://schemas.openxmlformats.org/drawingml/2006/chart">
@@ -17877,7 +17894,7 @@
         </p:spPr>
         <p:txBody>
           <a:bodyPr anchor="ctr">
-            <a:normAutofit/>
+            <a:noAutofit/>
           </a:bodyPr>
           <a:lstStyle/>
           <a:p>
@@ -17887,21 +17904,37 @@
             </a:r>
             <a:r>
               <a:rPr lang="en-US" dirty="0"/>
-              <a:t>/ARB use in DM with CKD by Race, </a:t>
+              <a:t>/ARB use in DM with CKD </a:t>
+            </a:r>
+            <a:r>
+              <a:rPr lang="en-US"/>
+              <a:t>by </a:t>
             </a:r>
             <a:br>
-              <a:rPr lang="en-US" dirty="0"/>
+              <a:rPr lang="en-US"/>
             </a:br>
             <a:r>
+              <a:rPr lang="en-US"/>
+              <a:t>Race/</a:t>
+            </a:r>
+            <a:r>
               <a:rPr lang="en-US" dirty="0"/>
-              <a:t>Age Standardized</a:t>
+              <a:t>Ethnicity</a:t>
+            </a:r>
+            <a:r>
+              <a:rPr lang="en-US"/>
+              <a:t>, Age </a:t>
+            </a:r>
+            <a:r>
+              <a:rPr lang="en-US" dirty="0"/>
+              <a:t>Standardized</a:t>
             </a:r>
           </a:p>
         </p:txBody>
       </p:sp>
       <p:graphicFrame>
         <p:nvGraphicFramePr>
-          <p:cNvPr id="7" name="Chart 6">
+          <p:cNvPr id="5" name="Chart 4">
             <a:extLst>
               <a:ext uri="{FF2B5EF4-FFF2-40B4-BE49-F238E27FC236}">
                 <a16:creationId xmlns:a16="http://schemas.microsoft.com/office/drawing/2014/main" id="{06A861E8-7DDB-9533-315E-4B22E740DA08}"/>
@@ -17914,7 +17947,7 @@
           <p:nvPr>
             <p:extLst>
               <p:ext uri="{D42A27DB-BD31-4B8C-83A1-F6EECF244321}">
-                <p14:modId xmlns:p14="http://schemas.microsoft.com/office/powerpoint/2010/main" val="1963177250"/>
+                <p14:modId xmlns:p14="http://schemas.microsoft.com/office/powerpoint/2010/main" val="713780292"/>
               </p:ext>
             </p:extLst>
           </p:nvPr>
@@ -18006,10 +18039,10 @@
       </p:sp>
       <p:graphicFrame>
         <p:nvGraphicFramePr>
-          <p:cNvPr id="6" name="Chart 5">
+          <p:cNvPr id="9" name="Chart 8">
             <a:extLst>
               <a:ext uri="{FF2B5EF4-FFF2-40B4-BE49-F238E27FC236}">
-                <a16:creationId xmlns:a16="http://schemas.microsoft.com/office/drawing/2014/main" id="{2B3E3BAA-0671-4CA9-AB5E-5ADF577F2A84}"/>
+                <a16:creationId xmlns:a16="http://schemas.microsoft.com/office/drawing/2014/main" id="{2018BFF9-F8E2-4F33-A211-DBEF9E3818F5}"/>
               </a:ext>
             </a:extLst>
           </p:cNvPr>
@@ -18019,7 +18052,7 @@
           <p:nvPr>
             <p:extLst>
               <p:ext uri="{D42A27DB-BD31-4B8C-83A1-F6EECF244321}">
-                <p14:modId xmlns:p14="http://schemas.microsoft.com/office/powerpoint/2010/main" val="133188143"/>
+                <p14:modId xmlns:p14="http://schemas.microsoft.com/office/powerpoint/2010/main" val="1145563012"/>
               </p:ext>
             </p:extLst>
           </p:nvPr>

</xml_diff>

<commit_message>
Q812,Q813, Q814, Q815 PPT and 508c compliance
</commit_message>
<xml_diff>
--- a/CKDSurveillance/PPT/Q814.pptx
+++ b/CKDSurveillance/PPT/Q814.pptx
@@ -3369,10 +3369,10 @@
           <c:layoutTarget val="inner"/>
           <c:xMode val="edge"/>
           <c:yMode val="edge"/>
-          <c:x val="8.924757471614389E-2"/>
-          <c:y val="4.7798556430446192E-2"/>
-          <c:w val="0.89853021272893374"/>
-          <c:h val="0.54443788276465443"/>
+          <c:x val="0.11506027996500437"/>
+          <c:y val="5.457633420822397E-2"/>
+          <c:w val="0.87271749781277341"/>
+          <c:h val="0.59671128608923885"/>
         </c:manualLayout>
       </c:layout>
       <c:lineChart>
@@ -3484,7 +3484,7 @@
           <c:smooth val="0"/>
           <c:extLst>
             <c:ext xmlns:c16="http://schemas.microsoft.com/office/drawing/2014/chart" uri="{C3380CC4-5D6E-409C-BE32-E72D297353CC}">
-              <c16:uniqueId val="{00000000-7E12-43A2-B958-1C7081544E01}"/>
+              <c16:uniqueId val="{00000000-2906-41F3-947A-594F7CC32F6B}"/>
             </c:ext>
           </c:extLst>
         </c:ser>
@@ -3594,7 +3594,7 @@
           <c:smooth val="0"/>
           <c:extLst>
             <c:ext xmlns:c16="http://schemas.microsoft.com/office/drawing/2014/chart" uri="{C3380CC4-5D6E-409C-BE32-E72D297353CC}">
-              <c16:uniqueId val="{00000001-7E12-43A2-B958-1C7081544E01}"/>
+              <c16:uniqueId val="{00000001-2906-41F3-947A-594F7CC32F6B}"/>
             </c:ext>
           </c:extLst>
         </c:ser>
@@ -3704,7 +3704,7 @@
           <c:smooth val="0"/>
           <c:extLst>
             <c:ext xmlns:c16="http://schemas.microsoft.com/office/drawing/2014/chart" uri="{C3380CC4-5D6E-409C-BE32-E72D297353CC}">
-              <c16:uniqueId val="{00000002-7E12-43A2-B958-1C7081544E01}"/>
+              <c16:uniqueId val="{00000002-2906-41F3-947A-594F7CC32F6B}"/>
             </c:ext>
           </c:extLst>
         </c:ser>
@@ -3717,7 +3717,7 @@
               <c:strCache>
                 <c:ptCount val="1"/>
                 <c:pt idx="0">
-                  <c:v>Native American/Alaska Native</c:v>
+                  <c:v>American Indian/Alaska Native</c:v>
                 </c:pt>
               </c:strCache>
             </c:strRef>
@@ -3814,7 +3814,7 @@
           <c:smooth val="0"/>
           <c:extLst>
             <c:ext xmlns:c16="http://schemas.microsoft.com/office/drawing/2014/chart" uri="{C3380CC4-5D6E-409C-BE32-E72D297353CC}">
-              <c16:uniqueId val="{00000003-7E12-43A2-B958-1C7081544E01}"/>
+              <c16:uniqueId val="{00000003-2906-41F3-947A-594F7CC32F6B}"/>
             </c:ext>
           </c:extLst>
         </c:ser>
@@ -3924,245 +3924,13 @@
           <c:smooth val="0"/>
           <c:extLst>
             <c:ext xmlns:c16="http://schemas.microsoft.com/office/drawing/2014/chart" uri="{C3380CC4-5D6E-409C-BE32-E72D297353CC}">
-              <c16:uniqueId val="{00000004-7E12-43A2-B958-1C7081544E01}"/>
-            </c:ext>
-          </c:extLst>
-        </c:ser>
-        <c:ser>
-          <c:idx val="6"/>
-          <c:order val="5"/>
-          <c:tx>
-            <c:strRef>
-              <c:f>'ACEI-ARB DM-CKD by Race'!$B$71</c:f>
-              <c:strCache>
-                <c:ptCount val="1"/>
-                <c:pt idx="0">
-                  <c:v>Unknown</c:v>
-                </c:pt>
-              </c:strCache>
-            </c:strRef>
-          </c:tx>
-          <c:spPr>
-            <a:ln w="44450" cap="rnd">
-              <a:solidFill>
-                <a:schemeClr val="accent1">
-                  <a:lumMod val="60000"/>
-                </a:schemeClr>
-              </a:solidFill>
-              <a:round/>
-            </a:ln>
-            <a:effectLst/>
-          </c:spPr>
-          <c:marker>
-            <c:symbol val="circle"/>
-            <c:size val="5"/>
-            <c:spPr>
-              <a:solidFill>
-                <a:schemeClr val="accent1">
-                  <a:lumMod val="60000"/>
-                </a:schemeClr>
-              </a:solidFill>
-              <a:ln w="9525">
-                <a:solidFill>
-                  <a:schemeClr val="accent1">
-                    <a:lumMod val="60000"/>
-                  </a:schemeClr>
-                </a:solidFill>
-              </a:ln>
-              <a:effectLst/>
-            </c:spPr>
-          </c:marker>
-          <c:cat>
-            <c:strRef>
-              <c:f>'ACEI-ARB DM-CKD by Race'!$C$64:$J$64</c:f>
-              <c:strCache>
-                <c:ptCount val="8"/>
-                <c:pt idx="0">
-                  <c:v>2016</c:v>
-                </c:pt>
-                <c:pt idx="1">
-                  <c:v>2017</c:v>
-                </c:pt>
-                <c:pt idx="2">
-                  <c:v>2018</c:v>
-                </c:pt>
-                <c:pt idx="3">
-                  <c:v>2019</c:v>
-                </c:pt>
-                <c:pt idx="4">
-                  <c:v>2020</c:v>
-                </c:pt>
-                <c:pt idx="5">
-                  <c:v>2021</c:v>
-                </c:pt>
-                <c:pt idx="6">
-                  <c:v>2022</c:v>
-                </c:pt>
-                <c:pt idx="7">
-                  <c:v>2023</c:v>
-                </c:pt>
-              </c:strCache>
-            </c:strRef>
-          </c:cat>
-          <c:val>
-            <c:numRef>
-              <c:f>'ACEI-ARB DM-CKD by Race'!$C$71:$J$71</c:f>
-              <c:numCache>
-                <c:formatCode>General</c:formatCode>
-                <c:ptCount val="8"/>
-                <c:pt idx="0">
-                  <c:v>76.459999999999994</c:v>
-                </c:pt>
-                <c:pt idx="1">
-                  <c:v>74.81</c:v>
-                </c:pt>
-                <c:pt idx="2">
-                  <c:v>73.88</c:v>
-                </c:pt>
-                <c:pt idx="3">
-                  <c:v>72.650000000000006</c:v>
-                </c:pt>
-                <c:pt idx="4">
-                  <c:v>71.48</c:v>
-                </c:pt>
-                <c:pt idx="5">
-                  <c:v>70.22</c:v>
-                </c:pt>
-                <c:pt idx="6">
-                  <c:v>70.150000000000006</c:v>
-                </c:pt>
-                <c:pt idx="7">
-                  <c:v>70.069999999999993</c:v>
-                </c:pt>
-              </c:numCache>
-            </c:numRef>
-          </c:val>
-          <c:smooth val="0"/>
-          <c:extLst>
-            <c:ext xmlns:c16="http://schemas.microsoft.com/office/drawing/2014/chart" uri="{C3380CC4-5D6E-409C-BE32-E72D297353CC}">
-              <c16:uniqueId val="{00000005-7E12-43A2-B958-1C7081544E01}"/>
-            </c:ext>
-          </c:extLst>
-        </c:ser>
-        <c:ser>
-          <c:idx val="7"/>
-          <c:order val="6"/>
-          <c:tx>
-            <c:strRef>
-              <c:f>'ACEI-ARB DM-CKD by Race'!$B$72</c:f>
-              <c:strCache>
-                <c:ptCount val="1"/>
-                <c:pt idx="0">
-                  <c:v>Missing</c:v>
-                </c:pt>
-              </c:strCache>
-            </c:strRef>
-          </c:tx>
-          <c:spPr>
-            <a:ln w="44450" cap="rnd">
-              <a:solidFill>
-                <a:schemeClr val="accent2">
-                  <a:lumMod val="60000"/>
-                </a:schemeClr>
-              </a:solidFill>
-              <a:round/>
-            </a:ln>
-            <a:effectLst/>
-          </c:spPr>
-          <c:marker>
-            <c:symbol val="circle"/>
-            <c:size val="5"/>
-            <c:spPr>
-              <a:solidFill>
-                <a:schemeClr val="accent2">
-                  <a:lumMod val="60000"/>
-                </a:schemeClr>
-              </a:solidFill>
-              <a:ln w="9525">
-                <a:solidFill>
-                  <a:schemeClr val="accent2">
-                    <a:lumMod val="60000"/>
-                  </a:schemeClr>
-                </a:solidFill>
-              </a:ln>
-              <a:effectLst/>
-            </c:spPr>
-          </c:marker>
-          <c:cat>
-            <c:strRef>
-              <c:f>'ACEI-ARB DM-CKD by Race'!$C$64:$J$64</c:f>
-              <c:strCache>
-                <c:ptCount val="8"/>
-                <c:pt idx="0">
-                  <c:v>2016</c:v>
-                </c:pt>
-                <c:pt idx="1">
-                  <c:v>2017</c:v>
-                </c:pt>
-                <c:pt idx="2">
-                  <c:v>2018</c:v>
-                </c:pt>
-                <c:pt idx="3">
-                  <c:v>2019</c:v>
-                </c:pt>
-                <c:pt idx="4">
-                  <c:v>2020</c:v>
-                </c:pt>
-                <c:pt idx="5">
-                  <c:v>2021</c:v>
-                </c:pt>
-                <c:pt idx="6">
-                  <c:v>2022</c:v>
-                </c:pt>
-                <c:pt idx="7">
-                  <c:v>2023</c:v>
-                </c:pt>
-              </c:strCache>
-            </c:strRef>
-          </c:cat>
-          <c:val>
-            <c:numRef>
-              <c:f>'ACEI-ARB DM-CKD by Race'!$C$72:$J$72</c:f>
-              <c:numCache>
-                <c:formatCode>General</c:formatCode>
-                <c:ptCount val="8"/>
-                <c:pt idx="0">
-                  <c:v>77.7</c:v>
-                </c:pt>
-                <c:pt idx="1">
-                  <c:v>76.75</c:v>
-                </c:pt>
-                <c:pt idx="2">
-                  <c:v>75.83</c:v>
-                </c:pt>
-                <c:pt idx="3">
-                  <c:v>75.28</c:v>
-                </c:pt>
-                <c:pt idx="4">
-                  <c:v>73.7</c:v>
-                </c:pt>
-                <c:pt idx="5">
-                  <c:v>72.98</c:v>
-                </c:pt>
-                <c:pt idx="6">
-                  <c:v>73.680000000000007</c:v>
-                </c:pt>
-                <c:pt idx="7">
-                  <c:v>73.89</c:v>
-                </c:pt>
-              </c:numCache>
-            </c:numRef>
-          </c:val>
-          <c:smooth val="0"/>
-          <c:extLst>
-            <c:ext xmlns:c16="http://schemas.microsoft.com/office/drawing/2014/chart" uri="{C3380CC4-5D6E-409C-BE32-E72D297353CC}">
-              <c16:uniqueId val="{00000006-7E12-43A2-B958-1C7081544E01}"/>
+              <c16:uniqueId val="{00000004-2906-41F3-947A-594F7CC32F6B}"/>
             </c:ext>
           </c:extLst>
         </c:ser>
         <c:ser>
           <c:idx val="0"/>
-          <c:order val="7"/>
+          <c:order val="5"/>
           <c:tx>
             <c:strRef>
               <c:f>'ACEI-ARB DM-CKD by Race'!$B$65</c:f>
@@ -4267,7 +4035,7 @@
           <c:smooth val="0"/>
           <c:extLst>
             <c:ext xmlns:c16="http://schemas.microsoft.com/office/drawing/2014/chart" uri="{C3380CC4-5D6E-409C-BE32-E72D297353CC}">
-              <c16:uniqueId val="{00000007-7E12-43A2-B958-1C7081544E01}"/>
+              <c16:uniqueId val="{00000007-2906-41F3-947A-594F7CC32F6B}"/>
             </c:ext>
           </c:extLst>
         </c:ser>
@@ -4336,6 +4104,7 @@
         <c:axId val="1024697664"/>
         <c:scaling>
           <c:orientation val="minMax"/>
+          <c:min val="0"/>
         </c:scaling>
         <c:delete val="0"/>
         <c:axPos val="l"/>
@@ -4370,20 +4139,9 @@
                   </a:defRPr>
                 </a:pPr>
                 <a:r>
-                  <a:rPr lang="en-US" sz="2000" b="0" i="0" baseline="0" dirty="0" err="1">
-                    <a:effectLst/>
-                  </a:rPr>
-                  <a:t>ACEi</a:t>
+                  <a:rPr lang="en-US"/>
+                  <a:t>ACEi/ARB use (%)</a:t>
                 </a:r>
-                <a:r>
-                  <a:rPr lang="en-US" sz="2000" b="0" i="0" baseline="0" dirty="0">
-                    <a:effectLst/>
-                  </a:rPr>
-                  <a:t>/ARB use (%)</a:t>
-                </a:r>
-                <a:endParaRPr lang="en-US" sz="2000" dirty="0">
-                  <a:effectLst/>
-                </a:endParaRPr>
               </a:p>
             </c:rich>
           </c:tx>
@@ -4445,6 +4203,7 @@
         <c:crossAx val="1024696704"/>
         <c:crosses val="autoZero"/>
         <c:crossBetween val="between"/>
+        <c:majorUnit val="20"/>
       </c:valAx>
       <c:spPr>
         <a:noFill/>
@@ -4460,10 +4219,10 @@
         <c:manualLayout>
           <c:xMode val="edge"/>
           <c:yMode val="edge"/>
-          <c:x val="9.660542432195975E-4"/>
-          <c:y val="0.73469947506561695"/>
-          <c:w val="0.99695678040244973"/>
-          <c:h val="0.19863385826771654"/>
+          <c:x val="4.2169728783902021E-4"/>
+          <c:y val="0.76247725284339463"/>
+          <c:w val="0.99804549431321088"/>
+          <c:h val="0.22085608048993879"/>
         </c:manualLayout>
       </c:layout>
       <c:overlay val="0"/>
@@ -4546,10 +4305,10 @@
           <c:layoutTarget val="inner"/>
           <c:xMode val="edge"/>
           <c:yMode val="edge"/>
-          <c:x val="0.11562335958005249"/>
-          <c:y val="4.7798556430446192E-2"/>
-          <c:w val="0.87215441819772532"/>
-          <c:h val="0.57221566054243211"/>
+          <c:x val="0.11506027996500437"/>
+          <c:y val="5.457633420822397E-2"/>
+          <c:w val="0.87271749781277341"/>
+          <c:h val="0.59115573053368331"/>
         </c:manualLayout>
       </c:layout>
       <c:lineChart>
@@ -4661,7 +4420,7 @@
           <c:smooth val="0"/>
           <c:extLst>
             <c:ext xmlns:c16="http://schemas.microsoft.com/office/drawing/2014/chart" uri="{C3380CC4-5D6E-409C-BE32-E72D297353CC}">
-              <c16:uniqueId val="{00000000-8442-4D93-B195-0A5CC7CAFA48}"/>
+              <c16:uniqueId val="{00000000-E772-4FBF-BB09-8583C4201241}"/>
             </c:ext>
           </c:extLst>
         </c:ser>
@@ -4771,7 +4530,7 @@
           <c:smooth val="0"/>
           <c:extLst>
             <c:ext xmlns:c16="http://schemas.microsoft.com/office/drawing/2014/chart" uri="{C3380CC4-5D6E-409C-BE32-E72D297353CC}">
-              <c16:uniqueId val="{00000001-8442-4D93-B195-0A5CC7CAFA48}"/>
+              <c16:uniqueId val="{00000001-E772-4FBF-BB09-8583C4201241}"/>
             </c:ext>
           </c:extLst>
         </c:ser>
@@ -4881,7 +4640,7 @@
           <c:smooth val="0"/>
           <c:extLst>
             <c:ext xmlns:c16="http://schemas.microsoft.com/office/drawing/2014/chart" uri="{C3380CC4-5D6E-409C-BE32-E72D297353CC}">
-              <c16:uniqueId val="{00000002-8442-4D93-B195-0A5CC7CAFA48}"/>
+              <c16:uniqueId val="{00000002-E772-4FBF-BB09-8583C4201241}"/>
             </c:ext>
           </c:extLst>
         </c:ser>
@@ -4894,7 +4653,7 @@
               <c:strCache>
                 <c:ptCount val="1"/>
                 <c:pt idx="0">
-                  <c:v>Native American/Alaska Native</c:v>
+                  <c:v>American Indian/Alaska Native</c:v>
                 </c:pt>
               </c:strCache>
             </c:strRef>
@@ -4991,7 +4750,7 @@
           <c:smooth val="0"/>
           <c:extLst>
             <c:ext xmlns:c16="http://schemas.microsoft.com/office/drawing/2014/chart" uri="{C3380CC4-5D6E-409C-BE32-E72D297353CC}">
-              <c16:uniqueId val="{00000003-8442-4D93-B195-0A5CC7CAFA48}"/>
+              <c16:uniqueId val="{00000003-E772-4FBF-BB09-8583C4201241}"/>
             </c:ext>
           </c:extLst>
         </c:ser>
@@ -5101,245 +4860,13 @@
           <c:smooth val="0"/>
           <c:extLst>
             <c:ext xmlns:c16="http://schemas.microsoft.com/office/drawing/2014/chart" uri="{C3380CC4-5D6E-409C-BE32-E72D297353CC}">
-              <c16:uniqueId val="{00000004-8442-4D93-B195-0A5CC7CAFA48}"/>
-            </c:ext>
-          </c:extLst>
-        </c:ser>
-        <c:ser>
-          <c:idx val="6"/>
-          <c:order val="5"/>
-          <c:tx>
-            <c:strRef>
-              <c:f>'ACEI-ARB DM-CKD by Race'!$B$83</c:f>
-              <c:strCache>
-                <c:ptCount val="1"/>
-                <c:pt idx="0">
-                  <c:v>Unknown</c:v>
-                </c:pt>
-              </c:strCache>
-            </c:strRef>
-          </c:tx>
-          <c:spPr>
-            <a:ln w="44450" cap="rnd">
-              <a:solidFill>
-                <a:schemeClr val="accent1">
-                  <a:lumMod val="60000"/>
-                </a:schemeClr>
-              </a:solidFill>
-              <a:round/>
-            </a:ln>
-            <a:effectLst/>
-          </c:spPr>
-          <c:marker>
-            <c:symbol val="circle"/>
-            <c:size val="5"/>
-            <c:spPr>
-              <a:solidFill>
-                <a:schemeClr val="accent1">
-                  <a:lumMod val="60000"/>
-                </a:schemeClr>
-              </a:solidFill>
-              <a:ln w="9525">
-                <a:solidFill>
-                  <a:schemeClr val="accent1">
-                    <a:lumMod val="60000"/>
-                  </a:schemeClr>
-                </a:solidFill>
-              </a:ln>
-              <a:effectLst/>
-            </c:spPr>
-          </c:marker>
-          <c:cat>
-            <c:strRef>
-              <c:f>'ACEI-ARB DM-CKD by Race'!$C$76:$J$76</c:f>
-              <c:strCache>
-                <c:ptCount val="8"/>
-                <c:pt idx="0">
-                  <c:v>2016</c:v>
-                </c:pt>
-                <c:pt idx="1">
-                  <c:v>2017</c:v>
-                </c:pt>
-                <c:pt idx="2">
-                  <c:v>2018</c:v>
-                </c:pt>
-                <c:pt idx="3">
-                  <c:v>2019</c:v>
-                </c:pt>
-                <c:pt idx="4">
-                  <c:v>2020</c:v>
-                </c:pt>
-                <c:pt idx="5">
-                  <c:v>2021</c:v>
-                </c:pt>
-                <c:pt idx="6">
-                  <c:v>2022</c:v>
-                </c:pt>
-                <c:pt idx="7">
-                  <c:v>2023</c:v>
-                </c:pt>
-              </c:strCache>
-            </c:strRef>
-          </c:cat>
-          <c:val>
-            <c:numRef>
-              <c:f>'ACEI-ARB DM-CKD by Race'!$C$83:$J$83</c:f>
-              <c:numCache>
-                <c:formatCode>0.00</c:formatCode>
-                <c:ptCount val="8"/>
-                <c:pt idx="0">
-                  <c:v>64.182299999999998</c:v>
-                </c:pt>
-                <c:pt idx="1">
-                  <c:v>63.257399999999997</c:v>
-                </c:pt>
-                <c:pt idx="2">
-                  <c:v>61.559600000000003</c:v>
-                </c:pt>
-                <c:pt idx="3">
-                  <c:v>62.393300000000004</c:v>
-                </c:pt>
-                <c:pt idx="4">
-                  <c:v>63.1843</c:v>
-                </c:pt>
-                <c:pt idx="5">
-                  <c:v>60.502600000000001</c:v>
-                </c:pt>
-                <c:pt idx="6">
-                  <c:v>62.910499999999999</c:v>
-                </c:pt>
-                <c:pt idx="7">
-                  <c:v>60.094000000000001</c:v>
-                </c:pt>
-              </c:numCache>
-            </c:numRef>
-          </c:val>
-          <c:smooth val="0"/>
-          <c:extLst>
-            <c:ext xmlns:c16="http://schemas.microsoft.com/office/drawing/2014/chart" uri="{C3380CC4-5D6E-409C-BE32-E72D297353CC}">
-              <c16:uniqueId val="{00000005-8442-4D93-B195-0A5CC7CAFA48}"/>
-            </c:ext>
-          </c:extLst>
-        </c:ser>
-        <c:ser>
-          <c:idx val="7"/>
-          <c:order val="6"/>
-          <c:tx>
-            <c:strRef>
-              <c:f>'ACEI-ARB DM-CKD by Race'!$B$84</c:f>
-              <c:strCache>
-                <c:ptCount val="1"/>
-                <c:pt idx="0">
-                  <c:v>Missing</c:v>
-                </c:pt>
-              </c:strCache>
-            </c:strRef>
-          </c:tx>
-          <c:spPr>
-            <a:ln w="44450" cap="rnd">
-              <a:solidFill>
-                <a:schemeClr val="accent2">
-                  <a:lumMod val="60000"/>
-                </a:schemeClr>
-              </a:solidFill>
-              <a:round/>
-            </a:ln>
-            <a:effectLst/>
-          </c:spPr>
-          <c:marker>
-            <c:symbol val="circle"/>
-            <c:size val="5"/>
-            <c:spPr>
-              <a:solidFill>
-                <a:schemeClr val="accent2">
-                  <a:lumMod val="60000"/>
-                </a:schemeClr>
-              </a:solidFill>
-              <a:ln w="9525">
-                <a:solidFill>
-                  <a:schemeClr val="accent2">
-                    <a:lumMod val="60000"/>
-                  </a:schemeClr>
-                </a:solidFill>
-              </a:ln>
-              <a:effectLst/>
-            </c:spPr>
-          </c:marker>
-          <c:cat>
-            <c:strRef>
-              <c:f>'ACEI-ARB DM-CKD by Race'!$C$76:$J$76</c:f>
-              <c:strCache>
-                <c:ptCount val="8"/>
-                <c:pt idx="0">
-                  <c:v>2016</c:v>
-                </c:pt>
-                <c:pt idx="1">
-                  <c:v>2017</c:v>
-                </c:pt>
-                <c:pt idx="2">
-                  <c:v>2018</c:v>
-                </c:pt>
-                <c:pt idx="3">
-                  <c:v>2019</c:v>
-                </c:pt>
-                <c:pt idx="4">
-                  <c:v>2020</c:v>
-                </c:pt>
-                <c:pt idx="5">
-                  <c:v>2021</c:v>
-                </c:pt>
-                <c:pt idx="6">
-                  <c:v>2022</c:v>
-                </c:pt>
-                <c:pt idx="7">
-                  <c:v>2023</c:v>
-                </c:pt>
-              </c:strCache>
-            </c:strRef>
-          </c:cat>
-          <c:val>
-            <c:numRef>
-              <c:f>'ACEI-ARB DM-CKD by Race'!$C$84:$J$84</c:f>
-              <c:numCache>
-                <c:formatCode>0.00</c:formatCode>
-                <c:ptCount val="8"/>
-                <c:pt idx="0">
-                  <c:v>66.183300000000003</c:v>
-                </c:pt>
-                <c:pt idx="1">
-                  <c:v>65.624399999999994</c:v>
-                </c:pt>
-                <c:pt idx="2">
-                  <c:v>62.434100000000001</c:v>
-                </c:pt>
-                <c:pt idx="3">
-                  <c:v>61.741</c:v>
-                </c:pt>
-                <c:pt idx="4">
-                  <c:v>59.9435</c:v>
-                </c:pt>
-                <c:pt idx="5">
-                  <c:v>59.089399999999998</c:v>
-                </c:pt>
-                <c:pt idx="6">
-                  <c:v>60.070399999999999</c:v>
-                </c:pt>
-                <c:pt idx="7">
-                  <c:v>61.1387</c:v>
-                </c:pt>
-              </c:numCache>
-            </c:numRef>
-          </c:val>
-          <c:smooth val="0"/>
-          <c:extLst>
-            <c:ext xmlns:c16="http://schemas.microsoft.com/office/drawing/2014/chart" uri="{C3380CC4-5D6E-409C-BE32-E72D297353CC}">
-              <c16:uniqueId val="{00000006-8442-4D93-B195-0A5CC7CAFA48}"/>
+              <c16:uniqueId val="{00000004-E772-4FBF-BB09-8583C4201241}"/>
             </c:ext>
           </c:extLst>
         </c:ser>
         <c:ser>
           <c:idx val="0"/>
-          <c:order val="7"/>
+          <c:order val="5"/>
           <c:tx>
             <c:strRef>
               <c:f>'ACEI-ARB DM-CKD by Race'!$B$77</c:f>
@@ -5444,7 +4971,7 @@
           <c:smooth val="0"/>
           <c:extLst>
             <c:ext xmlns:c16="http://schemas.microsoft.com/office/drawing/2014/chart" uri="{C3380CC4-5D6E-409C-BE32-E72D297353CC}">
-              <c16:uniqueId val="{00000007-8442-4D93-B195-0A5CC7CAFA48}"/>
+              <c16:uniqueId val="{00000007-E772-4FBF-BB09-8583C4201241}"/>
             </c:ext>
           </c:extLst>
         </c:ser>
@@ -5537,7 +5064,7 @@
               <a:bodyPr rot="-5400000" spcFirstLastPara="1" vertOverflow="ellipsis" vert="horz" wrap="square" anchor="ctr" anchorCtr="1"/>
               <a:lstStyle/>
               <a:p>
-                <a:pPr algn="ctr" rtl="0">
+                <a:pPr>
                   <a:defRPr sz="2000" b="0" i="0" u="none" strike="noStrike" kern="1200" baseline="0">
                     <a:solidFill>
                       <a:schemeClr val="tx1"/>
@@ -5548,8 +5075,8 @@
                   </a:defRPr>
                 </a:pPr>
                 <a:r>
-                  <a:rPr lang="en-US" dirty="0"/>
-                  <a:t>ACEI/ARB use (%)</a:t>
+                  <a:rPr lang="en-US"/>
+                  <a:t>ACEi/ARB use (%)</a:t>
                 </a:r>
               </a:p>
             </c:rich>
@@ -5566,7 +5093,7 @@
             <a:bodyPr rot="-5400000" spcFirstLastPara="1" vertOverflow="ellipsis" vert="horz" wrap="square" anchor="ctr" anchorCtr="1"/>
             <a:lstStyle/>
             <a:p>
-              <a:pPr algn="ctr" rtl="0">
+              <a:pPr>
                 <a:defRPr sz="2000" b="0" i="0" u="none" strike="noStrike" kern="1200" baseline="0">
                   <a:solidFill>
                     <a:schemeClr val="tx1"/>
@@ -5587,9 +5114,7 @@
         <c:spPr>
           <a:noFill/>
           <a:ln>
-            <a:solidFill>
-              <a:schemeClr val="tx1"/>
-            </a:solidFill>
+            <a:noFill/>
             <a:prstDash val="sysDash"/>
           </a:ln>
           <a:effectLst/>
@@ -5614,7 +5139,6 @@
         <c:crossAx val="1024696704"/>
         <c:crosses val="autoZero"/>
         <c:crossBetween val="between"/>
-        <c:majorUnit val="20"/>
       </c:valAx>
       <c:spPr>
         <a:noFill/>
@@ -5630,10 +5154,10 @@
         <c:manualLayout>
           <c:xMode val="edge"/>
           <c:yMode val="edge"/>
-          <c:x val="3.3107611548556467E-3"/>
-          <c:y val="0.74115791776027984"/>
-          <c:w val="0.99668923884514438"/>
-          <c:h val="0.20050874890638667"/>
+          <c:x val="4.2169728783902021E-4"/>
+          <c:y val="0.75136614173228344"/>
+          <c:w val="0.99804549431321088"/>
+          <c:h val="0.23196719160104987"/>
         </c:manualLayout>
       </c:layout>
       <c:overlay val="0"/>
@@ -5723,7 +5247,7 @@
               <c:strCache>
                 <c:ptCount val="1"/>
                 <c:pt idx="0">
-                  <c:v>Stage 1</c:v>
+                  <c:v>CKD Stage 1</c:v>
                 </c:pt>
               </c:strCache>
             </c:strRef>
@@ -5754,7 +5278,7 @@
           </c:marker>
           <c:cat>
             <c:strRef>
-              <c:f>'ACEI-ARB DM-CKD by CKD Stage'!$C$60:$J$60</c:f>
+              <c:f>'ACEI-ARB DM-CKD by CKD Stage'!$D$1:$K$1</c:f>
               <c:strCache>
                 <c:ptCount val="8"/>
                 <c:pt idx="0">
@@ -5820,7 +5344,7 @@
           <c:smooth val="0"/>
           <c:extLst>
             <c:ext xmlns:c16="http://schemas.microsoft.com/office/drawing/2014/chart" uri="{C3380CC4-5D6E-409C-BE32-E72D297353CC}">
-              <c16:uniqueId val="{00000001-A5AB-489D-8693-4F1E1C260284}"/>
+              <c16:uniqueId val="{00000000-4F65-4883-8DAB-9C9EE54AFBAB}"/>
             </c:ext>
           </c:extLst>
         </c:ser>
@@ -5833,7 +5357,7 @@
               <c:strCache>
                 <c:ptCount val="1"/>
                 <c:pt idx="0">
-                  <c:v>Stage 2</c:v>
+                  <c:v>CKD Stage 2</c:v>
                 </c:pt>
               </c:strCache>
             </c:strRef>
@@ -5864,7 +5388,7 @@
           </c:marker>
           <c:cat>
             <c:strRef>
-              <c:f>'ACEI-ARB DM-CKD by CKD Stage'!$C$60:$J$60</c:f>
+              <c:f>'ACEI-ARB DM-CKD by CKD Stage'!$D$1:$K$1</c:f>
               <c:strCache>
                 <c:ptCount val="8"/>
                 <c:pt idx="0">
@@ -5930,7 +5454,7 @@
           <c:smooth val="0"/>
           <c:extLst>
             <c:ext xmlns:c16="http://schemas.microsoft.com/office/drawing/2014/chart" uri="{C3380CC4-5D6E-409C-BE32-E72D297353CC}">
-              <c16:uniqueId val="{00000002-A5AB-489D-8693-4F1E1C260284}"/>
+              <c16:uniqueId val="{00000001-4F65-4883-8DAB-9C9EE54AFBAB}"/>
             </c:ext>
           </c:extLst>
         </c:ser>
@@ -5943,7 +5467,7 @@
               <c:strCache>
                 <c:ptCount val="1"/>
                 <c:pt idx="0">
-                  <c:v>Stage 3</c:v>
+                  <c:v>CKD Stage 3</c:v>
                 </c:pt>
               </c:strCache>
             </c:strRef>
@@ -5974,7 +5498,7 @@
           </c:marker>
           <c:cat>
             <c:strRef>
-              <c:f>'ACEI-ARB DM-CKD by CKD Stage'!$C$60:$J$60</c:f>
+              <c:f>'ACEI-ARB DM-CKD by CKD Stage'!$D$1:$K$1</c:f>
               <c:strCache>
                 <c:ptCount val="8"/>
                 <c:pt idx="0">
@@ -6040,7 +5564,7 @@
           <c:smooth val="0"/>
           <c:extLst>
             <c:ext xmlns:c16="http://schemas.microsoft.com/office/drawing/2014/chart" uri="{C3380CC4-5D6E-409C-BE32-E72D297353CC}">
-              <c16:uniqueId val="{00000003-A5AB-489D-8693-4F1E1C260284}"/>
+              <c16:uniqueId val="{00000002-4F65-4883-8DAB-9C9EE54AFBAB}"/>
             </c:ext>
           </c:extLst>
         </c:ser>
@@ -6053,7 +5577,7 @@
               <c:strCache>
                 <c:ptCount val="1"/>
                 <c:pt idx="0">
-                  <c:v>Stage 4</c:v>
+                  <c:v>CKD Stage 4</c:v>
                 </c:pt>
               </c:strCache>
             </c:strRef>
@@ -6084,7 +5608,7 @@
           </c:marker>
           <c:cat>
             <c:strRef>
-              <c:f>'ACEI-ARB DM-CKD by CKD Stage'!$C$60:$J$60</c:f>
+              <c:f>'ACEI-ARB DM-CKD by CKD Stage'!$D$1:$K$1</c:f>
               <c:strCache>
                 <c:ptCount val="8"/>
                 <c:pt idx="0">
@@ -6150,7 +5674,7 @@
           <c:smooth val="0"/>
           <c:extLst>
             <c:ext xmlns:c16="http://schemas.microsoft.com/office/drawing/2014/chart" uri="{C3380CC4-5D6E-409C-BE32-E72D297353CC}">
-              <c16:uniqueId val="{00000004-A5AB-489D-8693-4F1E1C260284}"/>
+              <c16:uniqueId val="{00000003-4F65-4883-8DAB-9C9EE54AFBAB}"/>
             </c:ext>
           </c:extLst>
         </c:ser>
@@ -6163,7 +5687,7 @@
               <c:strCache>
                 <c:ptCount val="1"/>
                 <c:pt idx="0">
-                  <c:v>Stage 5</c:v>
+                  <c:v>CKD Stage 5</c:v>
                 </c:pt>
               </c:strCache>
             </c:strRef>
@@ -6194,7 +5718,7 @@
           </c:marker>
           <c:cat>
             <c:strRef>
-              <c:f>'ACEI-ARB DM-CKD by CKD Stage'!$C$60:$J$60</c:f>
+              <c:f>'ACEI-ARB DM-CKD by CKD Stage'!$D$1:$K$1</c:f>
               <c:strCache>
                 <c:ptCount val="8"/>
                 <c:pt idx="0">
@@ -6260,245 +5784,13 @@
           <c:smooth val="0"/>
           <c:extLst>
             <c:ext xmlns:c16="http://schemas.microsoft.com/office/drawing/2014/chart" uri="{C3380CC4-5D6E-409C-BE32-E72D297353CC}">
-              <c16:uniqueId val="{00000005-A5AB-489D-8693-4F1E1C260284}"/>
-            </c:ext>
-          </c:extLst>
-        </c:ser>
-        <c:ser>
-          <c:idx val="6"/>
-          <c:order val="5"/>
-          <c:tx>
-            <c:strRef>
-              <c:f>'ACEI-ARB DM-CKD by CKD Stage'!$B$67</c:f>
-              <c:strCache>
-                <c:ptCount val="1"/>
-                <c:pt idx="0">
-                  <c:v>Unknown</c:v>
-                </c:pt>
-              </c:strCache>
-            </c:strRef>
-          </c:tx>
-          <c:spPr>
-            <a:ln w="44450" cap="rnd">
-              <a:solidFill>
-                <a:schemeClr val="accent1">
-                  <a:lumMod val="60000"/>
-                </a:schemeClr>
-              </a:solidFill>
-              <a:round/>
-            </a:ln>
-            <a:effectLst/>
-          </c:spPr>
-          <c:marker>
-            <c:symbol val="circle"/>
-            <c:size val="5"/>
-            <c:spPr>
-              <a:solidFill>
-                <a:schemeClr val="accent1">
-                  <a:lumMod val="60000"/>
-                </a:schemeClr>
-              </a:solidFill>
-              <a:ln w="9525">
-                <a:solidFill>
-                  <a:schemeClr val="accent1">
-                    <a:lumMod val="60000"/>
-                  </a:schemeClr>
-                </a:solidFill>
-              </a:ln>
-              <a:effectLst/>
-            </c:spPr>
-          </c:marker>
-          <c:cat>
-            <c:strRef>
-              <c:f>'ACEI-ARB DM-CKD by CKD Stage'!$C$60:$J$60</c:f>
-              <c:strCache>
-                <c:ptCount val="8"/>
-                <c:pt idx="0">
-                  <c:v>2016</c:v>
-                </c:pt>
-                <c:pt idx="1">
-                  <c:v>2017</c:v>
-                </c:pt>
-                <c:pt idx="2">
-                  <c:v>2018</c:v>
-                </c:pt>
-                <c:pt idx="3">
-                  <c:v>2019</c:v>
-                </c:pt>
-                <c:pt idx="4">
-                  <c:v>2020</c:v>
-                </c:pt>
-                <c:pt idx="5">
-                  <c:v>2021</c:v>
-                </c:pt>
-                <c:pt idx="6">
-                  <c:v>2022</c:v>
-                </c:pt>
-                <c:pt idx="7">
-                  <c:v>2023</c:v>
-                </c:pt>
-              </c:strCache>
-            </c:strRef>
-          </c:cat>
-          <c:val>
-            <c:numRef>
-              <c:f>'ACEI-ARB DM-CKD by CKD Stage'!$C$67:$J$67</c:f>
-              <c:numCache>
-                <c:formatCode>General</c:formatCode>
-                <c:ptCount val="8"/>
-                <c:pt idx="0">
-                  <c:v>78.41</c:v>
-                </c:pt>
-                <c:pt idx="1">
-                  <c:v>77.099999999999994</c:v>
-                </c:pt>
-                <c:pt idx="2">
-                  <c:v>77.069999999999993</c:v>
-                </c:pt>
-                <c:pt idx="3">
-                  <c:v>75.94</c:v>
-                </c:pt>
-                <c:pt idx="4">
-                  <c:v>74</c:v>
-                </c:pt>
-                <c:pt idx="5">
-                  <c:v>74.75</c:v>
-                </c:pt>
-                <c:pt idx="6">
-                  <c:v>73.819999999999993</c:v>
-                </c:pt>
-                <c:pt idx="7">
-                  <c:v>73.73</c:v>
-                </c:pt>
-              </c:numCache>
-            </c:numRef>
-          </c:val>
-          <c:smooth val="0"/>
-          <c:extLst>
-            <c:ext xmlns:c16="http://schemas.microsoft.com/office/drawing/2014/chart" uri="{C3380CC4-5D6E-409C-BE32-E72D297353CC}">
-              <c16:uniqueId val="{00000006-A5AB-489D-8693-4F1E1C260284}"/>
-            </c:ext>
-          </c:extLst>
-        </c:ser>
-        <c:ser>
-          <c:idx val="7"/>
-          <c:order val="6"/>
-          <c:tx>
-            <c:strRef>
-              <c:f>'ACEI-ARB DM-CKD by CKD Stage'!$B$68</c:f>
-              <c:strCache>
-                <c:ptCount val="1"/>
-                <c:pt idx="0">
-                  <c:v>Unmeasured</c:v>
-                </c:pt>
-              </c:strCache>
-            </c:strRef>
-          </c:tx>
-          <c:spPr>
-            <a:ln w="44450" cap="rnd">
-              <a:solidFill>
-                <a:schemeClr val="accent2">
-                  <a:lumMod val="60000"/>
-                </a:schemeClr>
-              </a:solidFill>
-              <a:round/>
-            </a:ln>
-            <a:effectLst/>
-          </c:spPr>
-          <c:marker>
-            <c:symbol val="circle"/>
-            <c:size val="5"/>
-            <c:spPr>
-              <a:solidFill>
-                <a:schemeClr val="accent2">
-                  <a:lumMod val="60000"/>
-                </a:schemeClr>
-              </a:solidFill>
-              <a:ln w="9525">
-                <a:solidFill>
-                  <a:schemeClr val="accent2">
-                    <a:lumMod val="60000"/>
-                  </a:schemeClr>
-                </a:solidFill>
-              </a:ln>
-              <a:effectLst/>
-            </c:spPr>
-          </c:marker>
-          <c:cat>
-            <c:strRef>
-              <c:f>'ACEI-ARB DM-CKD by CKD Stage'!$C$60:$J$60</c:f>
-              <c:strCache>
-                <c:ptCount val="8"/>
-                <c:pt idx="0">
-                  <c:v>2016</c:v>
-                </c:pt>
-                <c:pt idx="1">
-                  <c:v>2017</c:v>
-                </c:pt>
-                <c:pt idx="2">
-                  <c:v>2018</c:v>
-                </c:pt>
-                <c:pt idx="3">
-                  <c:v>2019</c:v>
-                </c:pt>
-                <c:pt idx="4">
-                  <c:v>2020</c:v>
-                </c:pt>
-                <c:pt idx="5">
-                  <c:v>2021</c:v>
-                </c:pt>
-                <c:pt idx="6">
-                  <c:v>2022</c:v>
-                </c:pt>
-                <c:pt idx="7">
-                  <c:v>2023</c:v>
-                </c:pt>
-              </c:strCache>
-            </c:strRef>
-          </c:cat>
-          <c:val>
-            <c:numRef>
-              <c:f>'ACEI-ARB DM-CKD by CKD Stage'!$C$68:$J$68</c:f>
-              <c:numCache>
-                <c:formatCode>General</c:formatCode>
-                <c:ptCount val="8"/>
-                <c:pt idx="0">
-                  <c:v>71.400000000000006</c:v>
-                </c:pt>
-                <c:pt idx="1">
-                  <c:v>71.47</c:v>
-                </c:pt>
-                <c:pt idx="2">
-                  <c:v>72.400000000000006</c:v>
-                </c:pt>
-                <c:pt idx="3">
-                  <c:v>69.77</c:v>
-                </c:pt>
-                <c:pt idx="4">
-                  <c:v>69.78</c:v>
-                </c:pt>
-                <c:pt idx="5">
-                  <c:v>67.59</c:v>
-                </c:pt>
-                <c:pt idx="6">
-                  <c:v>69.349999999999994</c:v>
-                </c:pt>
-                <c:pt idx="7">
-                  <c:v>68.25</c:v>
-                </c:pt>
-              </c:numCache>
-            </c:numRef>
-          </c:val>
-          <c:smooth val="0"/>
-          <c:extLst>
-            <c:ext xmlns:c16="http://schemas.microsoft.com/office/drawing/2014/chart" uri="{C3380CC4-5D6E-409C-BE32-E72D297353CC}">
-              <c16:uniqueId val="{00000007-A5AB-489D-8693-4F1E1C260284}"/>
+              <c16:uniqueId val="{00000004-4F65-4883-8DAB-9C9EE54AFBAB}"/>
             </c:ext>
           </c:extLst>
         </c:ser>
         <c:ser>
           <c:idx val="0"/>
-          <c:order val="7"/>
+          <c:order val="5"/>
           <c:tx>
             <c:strRef>
               <c:f>'ACEI-ARB DM-CKD by CKD Stage'!$B$61</c:f>
@@ -6537,7 +5829,7 @@
           </c:marker>
           <c:cat>
             <c:strRef>
-              <c:f>'ACEI-ARB DM-CKD by CKD Stage'!$C$60:$J$60</c:f>
+              <c:f>'ACEI-ARB DM-CKD by CKD Stage'!$D$1:$K$1</c:f>
               <c:strCache>
                 <c:ptCount val="8"/>
                 <c:pt idx="0">
@@ -6603,7 +5895,7 @@
           <c:smooth val="0"/>
           <c:extLst>
             <c:ext xmlns:c16="http://schemas.microsoft.com/office/drawing/2014/chart" uri="{C3380CC4-5D6E-409C-BE32-E72D297353CC}">
-              <c16:uniqueId val="{00000000-A5AB-489D-8693-4F1E1C260284}"/>
+              <c16:uniqueId val="{00000007-4F65-4883-8DAB-9C9EE54AFBAB}"/>
             </c:ext>
           </c:extLst>
         </c:ser>
@@ -6617,11 +5909,11 @@
         </c:dLbls>
         <c:marker val="1"/>
         <c:smooth val="0"/>
-        <c:axId val="710794735"/>
-        <c:axId val="710795567"/>
+        <c:axId val="421459343"/>
+        <c:axId val="421457679"/>
       </c:lineChart>
       <c:catAx>
-        <c:axId val="710794735"/>
+        <c:axId val="421459343"/>
         <c:scaling>
           <c:orientation val="minMax"/>
         </c:scaling>
@@ -6661,7 +5953,7 @@
             <a:endParaRPr lang="en-US"/>
           </a:p>
         </c:txPr>
-        <c:crossAx val="710795567"/>
+        <c:crossAx val="421457679"/>
         <c:crosses val="autoZero"/>
         <c:auto val="1"/>
         <c:lblAlgn val="ctr"/>
@@ -6669,7 +5961,7 @@
         <c:noMultiLvlLbl val="0"/>
       </c:catAx>
       <c:valAx>
-        <c:axId val="710795567"/>
+        <c:axId val="421457679"/>
         <c:scaling>
           <c:orientation val="minMax"/>
         </c:scaling>
@@ -6706,12 +5998,8 @@
                   </a:defRPr>
                 </a:pPr>
                 <a:r>
-                  <a:rPr lang="en-US" dirty="0" err="1"/>
-                  <a:t>ACEi</a:t>
-                </a:r>
-                <a:r>
-                  <a:rPr lang="en-US" dirty="0"/>
-                  <a:t>/ARB use (%)</a:t>
+                  <a:rPr lang="en-US"/>
+                  <a:t>ACEi/ARB use (%)</a:t>
                 </a:r>
               </a:p>
             </c:rich>
@@ -6770,7 +6058,7 @@
             <a:endParaRPr lang="en-US"/>
           </a:p>
         </c:txPr>
-        <c:crossAx val="710794735"/>
+        <c:crossAx val="421459343"/>
         <c:crosses val="autoZero"/>
         <c:crossBetween val="between"/>
       </c:valAx>
@@ -6788,10 +6076,10 @@
         <c:manualLayout>
           <c:xMode val="edge"/>
           <c:yMode val="edge"/>
-          <c:x val="1.0552930883639532E-3"/>
+          <c:x val="1.5499737532808396E-2"/>
           <c:y val="0.79304418197725279"/>
-          <c:w val="0.99894470691163606"/>
-          <c:h val="0.1375113735783027"/>
+          <c:w val="0.97344496937882752"/>
+          <c:h val="0.19028915135608049"/>
         </c:manualLayout>
       </c:layout>
       <c:overlay val="0"/>
@@ -6874,17 +6162,7 @@
   <c:chart>
     <c:autoTitleDeleted val="1"/>
     <c:plotArea>
-      <c:layout>
-        <c:manualLayout>
-          <c:layoutTarget val="inner"/>
-          <c:xMode val="edge"/>
-          <c:yMode val="edge"/>
-          <c:x val="9.8751093613298341E-2"/>
-          <c:y val="4.7798556430446192E-2"/>
-          <c:w val="0.88902668416447939"/>
-          <c:h val="0.68392455098807314"/>
-        </c:manualLayout>
-      </c:layout>
+      <c:layout/>
       <c:lineChart>
         <c:grouping val="standard"/>
         <c:varyColors val="0"/>
@@ -6897,7 +6175,7 @@
               <c:strCache>
                 <c:ptCount val="1"/>
                 <c:pt idx="0">
-                  <c:v>Stage 1</c:v>
+                  <c:v>CKD Stage 1</c:v>
                 </c:pt>
               </c:strCache>
             </c:strRef>
@@ -6994,7 +6272,7 @@
           <c:smooth val="0"/>
           <c:extLst>
             <c:ext xmlns:c16="http://schemas.microsoft.com/office/drawing/2014/chart" uri="{C3380CC4-5D6E-409C-BE32-E72D297353CC}">
-              <c16:uniqueId val="{00000000-A2C5-4586-BEA3-6A93D70CF345}"/>
+              <c16:uniqueId val="{00000000-CF16-4A53-A1DB-E7919E9530D7}"/>
             </c:ext>
           </c:extLst>
         </c:ser>
@@ -7007,7 +6285,7 @@
               <c:strCache>
                 <c:ptCount val="1"/>
                 <c:pt idx="0">
-                  <c:v>Stage 2</c:v>
+                  <c:v>CKD Stage 2</c:v>
                 </c:pt>
               </c:strCache>
             </c:strRef>
@@ -7104,7 +6382,7 @@
           <c:smooth val="0"/>
           <c:extLst>
             <c:ext xmlns:c16="http://schemas.microsoft.com/office/drawing/2014/chart" uri="{C3380CC4-5D6E-409C-BE32-E72D297353CC}">
-              <c16:uniqueId val="{00000001-A2C5-4586-BEA3-6A93D70CF345}"/>
+              <c16:uniqueId val="{00000001-CF16-4A53-A1DB-E7919E9530D7}"/>
             </c:ext>
           </c:extLst>
         </c:ser>
@@ -7117,7 +6395,7 @@
               <c:strCache>
                 <c:ptCount val="1"/>
                 <c:pt idx="0">
-                  <c:v>Stage 3</c:v>
+                  <c:v>CKD Stage 3</c:v>
                 </c:pt>
               </c:strCache>
             </c:strRef>
@@ -7214,7 +6492,7 @@
           <c:smooth val="0"/>
           <c:extLst>
             <c:ext xmlns:c16="http://schemas.microsoft.com/office/drawing/2014/chart" uri="{C3380CC4-5D6E-409C-BE32-E72D297353CC}">
-              <c16:uniqueId val="{00000002-A2C5-4586-BEA3-6A93D70CF345}"/>
+              <c16:uniqueId val="{00000002-CF16-4A53-A1DB-E7919E9530D7}"/>
             </c:ext>
           </c:extLst>
         </c:ser>
@@ -7227,7 +6505,7 @@
               <c:strCache>
                 <c:ptCount val="1"/>
                 <c:pt idx="0">
-                  <c:v>Stage 4</c:v>
+                  <c:v>CKD Stage 4</c:v>
                 </c:pt>
               </c:strCache>
             </c:strRef>
@@ -7324,7 +6602,7 @@
           <c:smooth val="0"/>
           <c:extLst>
             <c:ext xmlns:c16="http://schemas.microsoft.com/office/drawing/2014/chart" uri="{C3380CC4-5D6E-409C-BE32-E72D297353CC}">
-              <c16:uniqueId val="{00000003-A2C5-4586-BEA3-6A93D70CF345}"/>
+              <c16:uniqueId val="{00000003-CF16-4A53-A1DB-E7919E9530D7}"/>
             </c:ext>
           </c:extLst>
         </c:ser>
@@ -7337,7 +6615,7 @@
               <c:strCache>
                 <c:ptCount val="1"/>
                 <c:pt idx="0">
-                  <c:v>Stage 5</c:v>
+                  <c:v>CKD Stage 5</c:v>
                 </c:pt>
               </c:strCache>
             </c:strRef>
@@ -7434,245 +6712,13 @@
           <c:smooth val="0"/>
           <c:extLst>
             <c:ext xmlns:c16="http://schemas.microsoft.com/office/drawing/2014/chart" uri="{C3380CC4-5D6E-409C-BE32-E72D297353CC}">
-              <c16:uniqueId val="{00000004-A2C5-4586-BEA3-6A93D70CF345}"/>
-            </c:ext>
-          </c:extLst>
-        </c:ser>
-        <c:ser>
-          <c:idx val="6"/>
-          <c:order val="5"/>
-          <c:tx>
-            <c:strRef>
-              <c:f>'ACEI-ARB DM-CKD by CKD Stage'!$B$80</c:f>
-              <c:strCache>
-                <c:ptCount val="1"/>
-                <c:pt idx="0">
-                  <c:v>Unknown</c:v>
-                </c:pt>
-              </c:strCache>
-            </c:strRef>
-          </c:tx>
-          <c:spPr>
-            <a:ln w="44450" cap="rnd">
-              <a:solidFill>
-                <a:schemeClr val="accent1">
-                  <a:lumMod val="60000"/>
-                </a:schemeClr>
-              </a:solidFill>
-              <a:round/>
-            </a:ln>
-            <a:effectLst/>
-          </c:spPr>
-          <c:marker>
-            <c:symbol val="circle"/>
-            <c:size val="5"/>
-            <c:spPr>
-              <a:solidFill>
-                <a:schemeClr val="accent1">
-                  <a:lumMod val="60000"/>
-                </a:schemeClr>
-              </a:solidFill>
-              <a:ln w="9525">
-                <a:solidFill>
-                  <a:schemeClr val="accent1">
-                    <a:lumMod val="60000"/>
-                  </a:schemeClr>
-                </a:solidFill>
-              </a:ln>
-              <a:effectLst/>
-            </c:spPr>
-          </c:marker>
-          <c:cat>
-            <c:strRef>
-              <c:f>'ACEI-ARB DM-CKD by CKD Stage'!$C$73:$J$73</c:f>
-              <c:strCache>
-                <c:ptCount val="8"/>
-                <c:pt idx="0">
-                  <c:v>2016</c:v>
-                </c:pt>
-                <c:pt idx="1">
-                  <c:v>2017</c:v>
-                </c:pt>
-                <c:pt idx="2">
-                  <c:v>2018</c:v>
-                </c:pt>
-                <c:pt idx="3">
-                  <c:v>2019</c:v>
-                </c:pt>
-                <c:pt idx="4">
-                  <c:v>2020</c:v>
-                </c:pt>
-                <c:pt idx="5">
-                  <c:v>2021</c:v>
-                </c:pt>
-                <c:pt idx="6">
-                  <c:v>2022</c:v>
-                </c:pt>
-                <c:pt idx="7">
-                  <c:v>2023</c:v>
-                </c:pt>
-              </c:strCache>
-            </c:strRef>
-          </c:cat>
-          <c:val>
-            <c:numRef>
-              <c:f>'ACEI-ARB DM-CKD by CKD Stage'!$C$80:$J$80</c:f>
-              <c:numCache>
-                <c:formatCode>0.00</c:formatCode>
-                <c:ptCount val="8"/>
-                <c:pt idx="0">
-                  <c:v>64.131600000000006</c:v>
-                </c:pt>
-                <c:pt idx="1">
-                  <c:v>61.732799999999997</c:v>
-                </c:pt>
-                <c:pt idx="2">
-                  <c:v>66.069199999999995</c:v>
-                </c:pt>
-                <c:pt idx="3">
-                  <c:v>62.303699999999999</c:v>
-                </c:pt>
-                <c:pt idx="4">
-                  <c:v>62.236800000000002</c:v>
-                </c:pt>
-                <c:pt idx="5">
-                  <c:v>59.186300000000003</c:v>
-                </c:pt>
-                <c:pt idx="6">
-                  <c:v>62.089799999999997</c:v>
-                </c:pt>
-                <c:pt idx="7">
-                  <c:v>60.222999999999999</c:v>
-                </c:pt>
-              </c:numCache>
-            </c:numRef>
-          </c:val>
-          <c:smooth val="0"/>
-          <c:extLst>
-            <c:ext xmlns:c16="http://schemas.microsoft.com/office/drawing/2014/chart" uri="{C3380CC4-5D6E-409C-BE32-E72D297353CC}">
-              <c16:uniqueId val="{00000005-A2C5-4586-BEA3-6A93D70CF345}"/>
-            </c:ext>
-          </c:extLst>
-        </c:ser>
-        <c:ser>
-          <c:idx val="7"/>
-          <c:order val="6"/>
-          <c:tx>
-            <c:strRef>
-              <c:f>'ACEI-ARB DM-CKD by CKD Stage'!$B$81</c:f>
-              <c:strCache>
-                <c:ptCount val="1"/>
-                <c:pt idx="0">
-                  <c:v>Unmeasured</c:v>
-                </c:pt>
-              </c:strCache>
-            </c:strRef>
-          </c:tx>
-          <c:spPr>
-            <a:ln w="44450" cap="rnd">
-              <a:solidFill>
-                <a:schemeClr val="accent2">
-                  <a:lumMod val="60000"/>
-                </a:schemeClr>
-              </a:solidFill>
-              <a:round/>
-            </a:ln>
-            <a:effectLst/>
-          </c:spPr>
-          <c:marker>
-            <c:symbol val="circle"/>
-            <c:size val="5"/>
-            <c:spPr>
-              <a:solidFill>
-                <a:schemeClr val="accent2">
-                  <a:lumMod val="60000"/>
-                </a:schemeClr>
-              </a:solidFill>
-              <a:ln w="9525">
-                <a:solidFill>
-                  <a:schemeClr val="accent2">
-                    <a:lumMod val="60000"/>
-                  </a:schemeClr>
-                </a:solidFill>
-              </a:ln>
-              <a:effectLst/>
-            </c:spPr>
-          </c:marker>
-          <c:cat>
-            <c:strRef>
-              <c:f>'ACEI-ARB DM-CKD by CKD Stage'!$C$73:$J$73</c:f>
-              <c:strCache>
-                <c:ptCount val="8"/>
-                <c:pt idx="0">
-                  <c:v>2016</c:v>
-                </c:pt>
-                <c:pt idx="1">
-                  <c:v>2017</c:v>
-                </c:pt>
-                <c:pt idx="2">
-                  <c:v>2018</c:v>
-                </c:pt>
-                <c:pt idx="3">
-                  <c:v>2019</c:v>
-                </c:pt>
-                <c:pt idx="4">
-                  <c:v>2020</c:v>
-                </c:pt>
-                <c:pt idx="5">
-                  <c:v>2021</c:v>
-                </c:pt>
-                <c:pt idx="6">
-                  <c:v>2022</c:v>
-                </c:pt>
-                <c:pt idx="7">
-                  <c:v>2023</c:v>
-                </c:pt>
-              </c:strCache>
-            </c:strRef>
-          </c:cat>
-          <c:val>
-            <c:numRef>
-              <c:f>'ACEI-ARB DM-CKD by CKD Stage'!$C$81:$J$81</c:f>
-              <c:numCache>
-                <c:formatCode>0.00</c:formatCode>
-                <c:ptCount val="8"/>
-                <c:pt idx="0">
-                  <c:v>57.767299999999999</c:v>
-                </c:pt>
-                <c:pt idx="1">
-                  <c:v>61.294699999999999</c:v>
-                </c:pt>
-                <c:pt idx="2">
-                  <c:v>56.6295</c:v>
-                </c:pt>
-                <c:pt idx="3">
-                  <c:v>58.0745</c:v>
-                </c:pt>
-                <c:pt idx="4">
-                  <c:v>57.744199999999999</c:v>
-                </c:pt>
-                <c:pt idx="5">
-                  <c:v>55.700299999999999</c:v>
-                </c:pt>
-                <c:pt idx="6">
-                  <c:v>60.802700000000002</c:v>
-                </c:pt>
-                <c:pt idx="7">
-                  <c:v>55.692900000000002</c:v>
-                </c:pt>
-              </c:numCache>
-            </c:numRef>
-          </c:val>
-          <c:smooth val="0"/>
-          <c:extLst>
-            <c:ext xmlns:c16="http://schemas.microsoft.com/office/drawing/2014/chart" uri="{C3380CC4-5D6E-409C-BE32-E72D297353CC}">
-              <c16:uniqueId val="{00000006-A2C5-4586-BEA3-6A93D70CF345}"/>
+              <c16:uniqueId val="{00000004-CF16-4A53-A1DB-E7919E9530D7}"/>
             </c:ext>
           </c:extLst>
         </c:ser>
         <c:ser>
           <c:idx val="0"/>
-          <c:order val="7"/>
+          <c:order val="5"/>
           <c:tx>
             <c:strRef>
               <c:f>'ACEI-ARB DM-CKD by CKD Stage'!$B$74</c:f>
@@ -7777,7 +6823,7 @@
           <c:smooth val="0"/>
           <c:extLst>
             <c:ext xmlns:c16="http://schemas.microsoft.com/office/drawing/2014/chart" uri="{C3380CC4-5D6E-409C-BE32-E72D297353CC}">
-              <c16:uniqueId val="{00000007-A2C5-4586-BEA3-6A93D70CF345}"/>
+              <c16:uniqueId val="{00000007-CF16-4A53-A1DB-E7919E9530D7}"/>
             </c:ext>
           </c:extLst>
         </c:ser>
@@ -7846,7 +6892,6 @@
         <c:axId val="681524927"/>
         <c:scaling>
           <c:orientation val="minMax"/>
-          <c:max val="100"/>
         </c:scaling>
         <c:delete val="0"/>
         <c:axPos val="l"/>
@@ -7944,7 +6989,6 @@
         <c:crossAx val="681522015"/>
         <c:crosses val="autoZero"/>
         <c:crossBetween val="between"/>
-        <c:majorUnit val="20"/>
       </c:valAx>
       <c:spPr>
         <a:noFill/>
@@ -7956,34 +7000,14 @@
     </c:plotArea>
     <c:legend>
       <c:legendPos val="b"/>
-      <c:legendEntry>
-        <c:idx val="6"/>
-        <c:txPr>
-          <a:bodyPr rot="0" spcFirstLastPara="1" vertOverflow="ellipsis" vert="horz" wrap="square" anchor="ctr" anchorCtr="1"/>
-          <a:lstStyle/>
-          <a:p>
-            <a:pPr>
-              <a:defRPr sz="2400" b="0" i="0" u="none" strike="noStrike" kern="1200" baseline="0">
-                <a:solidFill>
-                  <a:schemeClr val="tx1"/>
-                </a:solidFill>
-                <a:latin typeface="+mn-lt"/>
-                <a:ea typeface="+mn-ea"/>
-                <a:cs typeface="+mn-cs"/>
-              </a:defRPr>
-            </a:pPr>
-            <a:endParaRPr lang="en-US"/>
-          </a:p>
-        </c:txPr>
-      </c:legendEntry>
       <c:layout>
         <c:manualLayout>
           <c:xMode val="edge"/>
           <c:yMode val="edge"/>
-          <c:x val="3.3333333333333335E-3"/>
-          <c:y val="0.77659196692547661"/>
-          <c:w val="0.9966666666666667"/>
-          <c:h val="0.2234080330745235"/>
+          <c:x val="1.5499737532808396E-2"/>
+          <c:y val="0.79304418197725279"/>
+          <c:w val="0.97900052493438305"/>
+          <c:h val="0.19028915135608049"/>
         </c:manualLayout>
       </c:layout>
       <c:overlay val="0"/>
@@ -13019,7 +12043,7 @@
           <a:p>
             <a:fld id="{0AF73B43-6A56-473B-AE2D-AB20CDBDB644}" type="datetimeFigureOut">
               <a:rPr lang="en-US" smtClean="0"/>
-              <a:t>10/21/2025</a:t>
+              <a:t>2/20/2026</a:t>
             </a:fld>
             <a:endParaRPr lang="en-US"/>
           </a:p>
@@ -13812,7 +12836,7 @@
           <a:p>
             <a:fld id="{740713D3-AB50-4A09-8DB2-7F26C27F2607}" type="datetimeFigureOut">
               <a:rPr lang="en-US" smtClean="0"/>
-              <a:t>10/21/2025</a:t>
+              <a:t>2/20/2026</a:t>
             </a:fld>
             <a:endParaRPr lang="en-US"/>
           </a:p>
@@ -14020,7 +13044,7 @@
           <a:p>
             <a:fld id="{740713D3-AB50-4A09-8DB2-7F26C27F2607}" type="datetimeFigureOut">
               <a:rPr lang="en-US" smtClean="0"/>
-              <a:t>10/21/2025</a:t>
+              <a:t>2/20/2026</a:t>
             </a:fld>
             <a:endParaRPr lang="en-US"/>
           </a:p>
@@ -14229,7 +13253,7 @@
           <a:p>
             <a:fld id="{740713D3-AB50-4A09-8DB2-7F26C27F2607}" type="datetimeFigureOut">
               <a:rPr lang="en-US" smtClean="0"/>
-              <a:t>10/21/2025</a:t>
+              <a:t>2/20/2026</a:t>
             </a:fld>
             <a:endParaRPr lang="en-US"/>
           </a:p>
@@ -14544,7 +13568,7 @@
           <a:p>
             <a:fld id="{740713D3-AB50-4A09-8DB2-7F26C27F2607}" type="datetimeFigureOut">
               <a:rPr lang="en-US" smtClean="0"/>
-              <a:t>10/21/2025</a:t>
+              <a:t>2/20/2026</a:t>
             </a:fld>
             <a:endParaRPr lang="en-US"/>
           </a:p>
@@ -14850,7 +13874,7 @@
           <a:p>
             <a:fld id="{740713D3-AB50-4A09-8DB2-7F26C27F2607}" type="datetimeFigureOut">
               <a:rPr lang="en-US" smtClean="0"/>
-              <a:t>10/21/2025</a:t>
+              <a:t>2/20/2026</a:t>
             </a:fld>
             <a:endParaRPr lang="en-US"/>
           </a:p>
@@ -15298,7 +14322,7 @@
           <a:p>
             <a:fld id="{740713D3-AB50-4A09-8DB2-7F26C27F2607}" type="datetimeFigureOut">
               <a:rPr lang="en-US" smtClean="0"/>
-              <a:t>10/21/2025</a:t>
+              <a:t>2/20/2026</a:t>
             </a:fld>
             <a:endParaRPr lang="en-US"/>
           </a:p>
@@ -15480,7 +14504,7 @@
           <a:p>
             <a:fld id="{740713D3-AB50-4A09-8DB2-7F26C27F2607}" type="datetimeFigureOut">
               <a:rPr lang="en-US" smtClean="0"/>
-              <a:t>10/21/2025</a:t>
+              <a:t>2/20/2026</a:t>
             </a:fld>
             <a:endParaRPr lang="en-US"/>
           </a:p>
@@ -15629,7 +14653,7 @@
           <a:p>
             <a:fld id="{740713D3-AB50-4A09-8DB2-7F26C27F2607}" type="datetimeFigureOut">
               <a:rPr lang="en-US" smtClean="0"/>
-              <a:t>10/21/2025</a:t>
+              <a:t>2/20/2026</a:t>
             </a:fld>
             <a:endParaRPr lang="en-US"/>
           </a:p>
@@ -15977,7 +15001,7 @@
           <a:p>
             <a:fld id="{740713D3-AB50-4A09-8DB2-7F26C27F2607}" type="datetimeFigureOut">
               <a:rPr lang="en-US" smtClean="0"/>
-              <a:t>10/21/2025</a:t>
+              <a:t>2/20/2026</a:t>
             </a:fld>
             <a:endParaRPr lang="en-US"/>
           </a:p>
@@ -16305,7 +15329,7 @@
           <a:p>
             <a:fld id="{740713D3-AB50-4A09-8DB2-7F26C27F2607}" type="datetimeFigureOut">
               <a:rPr lang="en-US" smtClean="0"/>
-              <a:t>10/21/2025</a:t>
+              <a:t>2/20/2026</a:t>
             </a:fld>
             <a:endParaRPr lang="en-US"/>
           </a:p>
@@ -16583,7 +15607,7 @@
           <a:p>
             <a:fld id="{740713D3-AB50-4A09-8DB2-7F26C27F2607}" type="datetimeFigureOut">
               <a:rPr lang="en-US" smtClean="0"/>
-              <a:t>10/21/2025</a:t>
+              <a:t>2/20/2026</a:t>
             </a:fld>
             <a:endParaRPr lang="en-US"/>
           </a:p>
@@ -17019,7 +16043,7 @@
         <p:spPr/>
         <p:txBody>
           <a:bodyPr>
-            <a:normAutofit fontScale="90000"/>
+            <a:normAutofit/>
           </a:bodyPr>
           <a:lstStyle/>
           <a:p>
@@ -17029,7 +16053,7 @@
             </a:r>
             <a:r>
               <a:rPr lang="en-US" dirty="0"/>
-              <a:t> or ARB use in Diabetes Mellitus (Types 1 and 2 DM) With Chronic Kidney Disease in the Military Health System </a:t>
+              <a:t>/ARB use in Diabetes Mellitus With Chronic Kidney Disease in the Military Health System </a:t>
             </a:r>
           </a:p>
         </p:txBody>
@@ -17165,7 +16189,7 @@
       </p:sp>
       <p:graphicFrame>
         <p:nvGraphicFramePr>
-          <p:cNvPr id="6" name="Chart 5">
+          <p:cNvPr id="4" name="Chart 3">
             <a:extLst>
               <a:ext uri="{FF2B5EF4-FFF2-40B4-BE49-F238E27FC236}">
                 <a16:creationId xmlns:a16="http://schemas.microsoft.com/office/drawing/2014/main" id="{6B68B2F7-0204-4B68-B563-9BAC1C265113}"/>
@@ -17178,14 +16202,14 @@
           <p:nvPr>
             <p:extLst>
               <p:ext uri="{D42A27DB-BD31-4B8C-83A1-F6EECF244321}">
-                <p14:modId xmlns:p14="http://schemas.microsoft.com/office/powerpoint/2010/main" val="1829083836"/>
+                <p14:modId xmlns:p14="http://schemas.microsoft.com/office/powerpoint/2010/main" val="1632729165"/>
               </p:ext>
             </p:extLst>
           </p:nvPr>
         </p:nvGraphicFramePr>
         <p:xfrm>
-          <a:off x="266700" y="1587500"/>
-          <a:ext cx="11734800" cy="4677437"/>
+          <a:off x="381000" y="1692937"/>
+          <a:ext cx="11430000" cy="4572000"/>
         </p:xfrm>
         <a:graphic>
           <a:graphicData uri="http://schemas.openxmlformats.org/drawingml/2006/chart">
@@ -17789,7 +16813,7 @@
       </p:sp>
       <p:graphicFrame>
         <p:nvGraphicFramePr>
-          <p:cNvPr id="6" name="Chart 5">
+          <p:cNvPr id="7" name="Chart 6">
             <a:extLst>
               <a:ext uri="{FF2B5EF4-FFF2-40B4-BE49-F238E27FC236}">
                 <a16:creationId xmlns:a16="http://schemas.microsoft.com/office/drawing/2014/main" id="{9E500B5D-E27D-AEB4-3100-897AF08653B2}"/>
@@ -17802,14 +16826,14 @@
           <p:nvPr>
             <p:extLst>
               <p:ext uri="{D42A27DB-BD31-4B8C-83A1-F6EECF244321}">
-                <p14:modId xmlns:p14="http://schemas.microsoft.com/office/powerpoint/2010/main" val="401832339"/>
+                <p14:modId xmlns:p14="http://schemas.microsoft.com/office/powerpoint/2010/main" val="1092530866"/>
               </p:ext>
             </p:extLst>
           </p:nvPr>
         </p:nvGraphicFramePr>
         <p:xfrm>
-          <a:off x="317500" y="1692937"/>
-          <a:ext cx="11493500" cy="4572000"/>
+          <a:off x="381000" y="1692937"/>
+          <a:ext cx="11430000" cy="4572000"/>
         </p:xfrm>
         <a:graphic>
           <a:graphicData uri="http://schemas.openxmlformats.org/drawingml/2006/chart">
@@ -17901,7 +16925,7 @@
       </p:sp>
       <p:graphicFrame>
         <p:nvGraphicFramePr>
-          <p:cNvPr id="7" name="Chart 6">
+          <p:cNvPr id="5" name="Chart 4">
             <a:extLst>
               <a:ext uri="{FF2B5EF4-FFF2-40B4-BE49-F238E27FC236}">
                 <a16:creationId xmlns:a16="http://schemas.microsoft.com/office/drawing/2014/main" id="{06A861E8-7DDB-9533-315E-4B22E740DA08}"/>
@@ -17914,7 +16938,7 @@
           <p:nvPr>
             <p:extLst>
               <p:ext uri="{D42A27DB-BD31-4B8C-83A1-F6EECF244321}">
-                <p14:modId xmlns:p14="http://schemas.microsoft.com/office/powerpoint/2010/main" val="1963177250"/>
+                <p14:modId xmlns:p14="http://schemas.microsoft.com/office/powerpoint/2010/main" val="1841575661"/>
               </p:ext>
             </p:extLst>
           </p:nvPr>
@@ -18006,10 +17030,10 @@
       </p:sp>
       <p:graphicFrame>
         <p:nvGraphicFramePr>
-          <p:cNvPr id="6" name="Chart 5">
+          <p:cNvPr id="9" name="Chart 8">
             <a:extLst>
               <a:ext uri="{FF2B5EF4-FFF2-40B4-BE49-F238E27FC236}">
-                <a16:creationId xmlns:a16="http://schemas.microsoft.com/office/drawing/2014/main" id="{2B3E3BAA-0671-4CA9-AB5E-5ADF577F2A84}"/>
+                <a16:creationId xmlns:a16="http://schemas.microsoft.com/office/drawing/2014/main" id="{2018BFF9-F8E2-4F33-A211-DBEF9E3818F5}"/>
               </a:ext>
             </a:extLst>
           </p:cNvPr>
@@ -18019,7 +17043,7 @@
           <p:nvPr>
             <p:extLst>
               <p:ext uri="{D42A27DB-BD31-4B8C-83A1-F6EECF244321}">
-                <p14:modId xmlns:p14="http://schemas.microsoft.com/office/powerpoint/2010/main" val="133188143"/>
+                <p14:modId xmlns:p14="http://schemas.microsoft.com/office/powerpoint/2010/main" val="1145563012"/>
               </p:ext>
             </p:extLst>
           </p:nvPr>
@@ -20050,4 +19074,225 @@
     </a:bgFillStyleLst>
   </a:fmtScheme>
 </a:themeOverride>
+</file>
+
+<file path=customXml/item1.xml><?xml version="1.0" encoding="utf-8"?>
+<ct:contentTypeSchema xmlns:ct="http://schemas.microsoft.com/office/2006/metadata/contentType" xmlns:ma="http://schemas.microsoft.com/office/2006/metadata/properties/metaAttributes" ct:_="" ma:_="" ma:contentTypeName="Document" ma:contentTypeID="0x01010050BC9B24C2BC4648A822105B302116B0" ma:contentTypeVersion="10" ma:contentTypeDescription="Create a new document." ma:contentTypeScope="" ma:versionID="581fb2d9703863f3db532522de69a7d8">
+  <xsd:schema xmlns:xsd="http://www.w3.org/2001/XMLSchema" xmlns:xs="http://www.w3.org/2001/XMLSchema" xmlns:p="http://schemas.microsoft.com/office/2006/metadata/properties" xmlns:ns2="5749bc8e-1545-4b42-a651-f1b0ccdc5fa5" xmlns:ns3="8e022c51-0240-47ac-b7b0-09a2f3086777" targetNamespace="http://schemas.microsoft.com/office/2006/metadata/properties" ma:root="true" ma:fieldsID="96cb22f3222442646e545c3c1fc94001" ns2:_="" ns3:_="">
+    <xsd:import namespace="5749bc8e-1545-4b42-a651-f1b0ccdc5fa5"/>
+    <xsd:import namespace="8e022c51-0240-47ac-b7b0-09a2f3086777"/>
+    <xsd:element name="properties">
+      <xsd:complexType>
+        <xsd:sequence>
+          <xsd:element name="documentManagement">
+            <xsd:complexType>
+              <xsd:all>
+                <xsd:element ref="ns2:MediaServiceMetadata" minOccurs="0"/>
+                <xsd:element ref="ns2:MediaServiceFastMetadata" minOccurs="0"/>
+                <xsd:element ref="ns2:MediaServiceSearchProperties" minOccurs="0"/>
+                <xsd:element ref="ns2:MediaServiceDateTaken" minOccurs="0"/>
+                <xsd:element ref="ns2:lcf76f155ced4ddcb4097134ff3c332f" minOccurs="0"/>
+                <xsd:element ref="ns3:TaxCatchAll" minOccurs="0"/>
+                <xsd:element ref="ns2:MediaServiceOCR" minOccurs="0"/>
+                <xsd:element ref="ns2:MediaServiceGenerationTime" minOccurs="0"/>
+                <xsd:element ref="ns2:MediaServiceEventHashCode" minOccurs="0"/>
+              </xsd:all>
+            </xsd:complexType>
+          </xsd:element>
+        </xsd:sequence>
+      </xsd:complexType>
+    </xsd:element>
+  </xsd:schema>
+  <xsd:schema xmlns:xsd="http://www.w3.org/2001/XMLSchema" xmlns:xs="http://www.w3.org/2001/XMLSchema" xmlns:dms="http://schemas.microsoft.com/office/2006/documentManagement/types" xmlns:pc="http://schemas.microsoft.com/office/infopath/2007/PartnerControls" targetNamespace="5749bc8e-1545-4b42-a651-f1b0ccdc5fa5" elementFormDefault="qualified">
+    <xsd:import namespace="http://schemas.microsoft.com/office/2006/documentManagement/types"/>
+    <xsd:import namespace="http://schemas.microsoft.com/office/infopath/2007/PartnerControls"/>
+    <xsd:element name="MediaServiceMetadata" ma:index="8" nillable="true" ma:displayName="MediaServiceMetadata" ma:hidden="true" ma:internalName="MediaServiceMetadata" ma:readOnly="true">
+      <xsd:simpleType>
+        <xsd:restriction base="dms:Note"/>
+      </xsd:simpleType>
+    </xsd:element>
+    <xsd:element name="MediaServiceFastMetadata" ma:index="9" nillable="true" ma:displayName="MediaServiceFastMetadata" ma:hidden="true" ma:internalName="MediaServiceFastMetadata" ma:readOnly="true">
+      <xsd:simpleType>
+        <xsd:restriction base="dms:Note"/>
+      </xsd:simpleType>
+    </xsd:element>
+    <xsd:element name="MediaServiceSearchProperties" ma:index="10" nillable="true" ma:displayName="MediaServiceSearchProperties" ma:hidden="true" ma:internalName="MediaServiceSearchProperties" ma:readOnly="true">
+      <xsd:simpleType>
+        <xsd:restriction base="dms:Note"/>
+      </xsd:simpleType>
+    </xsd:element>
+    <xsd:element name="MediaServiceDateTaken" ma:index="11" nillable="true" ma:displayName="MediaServiceDateTaken" ma:hidden="true" ma:indexed="true" ma:internalName="MediaServiceDateTaken" ma:readOnly="true">
+      <xsd:simpleType>
+        <xsd:restriction base="dms:Text"/>
+      </xsd:simpleType>
+    </xsd:element>
+    <xsd:element name="lcf76f155ced4ddcb4097134ff3c332f" ma:index="13" nillable="true" ma:taxonomy="true" ma:internalName="lcf76f155ced4ddcb4097134ff3c332f" ma:taxonomyFieldName="MediaServiceImageTags" ma:displayName="Image Tags" ma:readOnly="false" ma:fieldId="{5cf76f15-5ced-4ddc-b409-7134ff3c332f}" ma:taxonomyMulti="true" ma:sspId="cae6c5d7-b21f-4aaa-ac91-296ecc6194c0" ma:termSetId="09814cd3-568e-fe90-9814-8d621ff8fb84" ma:anchorId="fba54fb3-c3e1-fe81-a776-ca4b69148c4d" ma:open="true" ma:isKeyword="false">
+      <xsd:complexType>
+        <xsd:sequence>
+          <xsd:element ref="pc:Terms" minOccurs="0" maxOccurs="1"/>
+        </xsd:sequence>
+      </xsd:complexType>
+    </xsd:element>
+    <xsd:element name="MediaServiceOCR" ma:index="15" nillable="true" ma:displayName="Extracted Text" ma:internalName="MediaServiceOCR" ma:readOnly="true">
+      <xsd:simpleType>
+        <xsd:restriction base="dms:Note">
+          <xsd:maxLength value="255"/>
+        </xsd:restriction>
+      </xsd:simpleType>
+    </xsd:element>
+    <xsd:element name="MediaServiceGenerationTime" ma:index="16" nillable="true" ma:displayName="MediaServiceGenerationTime" ma:hidden="true" ma:internalName="MediaServiceGenerationTime" ma:readOnly="true">
+      <xsd:simpleType>
+        <xsd:restriction base="dms:Text"/>
+      </xsd:simpleType>
+    </xsd:element>
+    <xsd:element name="MediaServiceEventHashCode" ma:index="17" nillable="true" ma:displayName="MediaServiceEventHashCode" ma:hidden="true" ma:internalName="MediaServiceEventHashCode" ma:readOnly="true">
+      <xsd:simpleType>
+        <xsd:restriction base="dms:Text"/>
+      </xsd:simpleType>
+    </xsd:element>
+  </xsd:schema>
+  <xsd:schema xmlns:xsd="http://www.w3.org/2001/XMLSchema" xmlns:xs="http://www.w3.org/2001/XMLSchema" xmlns:dms="http://schemas.microsoft.com/office/2006/documentManagement/types" xmlns:pc="http://schemas.microsoft.com/office/infopath/2007/PartnerControls" targetNamespace="8e022c51-0240-47ac-b7b0-09a2f3086777" elementFormDefault="qualified">
+    <xsd:import namespace="http://schemas.microsoft.com/office/2006/documentManagement/types"/>
+    <xsd:import namespace="http://schemas.microsoft.com/office/infopath/2007/PartnerControls"/>
+    <xsd:element name="TaxCatchAll" ma:index="14" nillable="true" ma:displayName="Taxonomy Catch All Column" ma:hidden="true" ma:list="{4f07c378-3462-46dc-a28e-833745c64bfd}" ma:internalName="TaxCatchAll" ma:showField="CatchAllData" ma:web="8e022c51-0240-47ac-b7b0-09a2f3086777">
+      <xsd:complexType>
+        <xsd:complexContent>
+          <xsd:extension base="dms:MultiChoiceLookup">
+            <xsd:sequence>
+              <xsd:element name="Value" type="dms:Lookup" maxOccurs="unbounded" minOccurs="0" nillable="true"/>
+            </xsd:sequence>
+          </xsd:extension>
+        </xsd:complexContent>
+      </xsd:complexType>
+    </xsd:element>
+  </xsd:schema>
+  <xsd:schema xmlns="http://schemas.openxmlformats.org/package/2006/metadata/core-properties" xmlns:xsd="http://www.w3.org/2001/XMLSchema" xmlns:xsi="http://www.w3.org/2001/XMLSchema-instance" xmlns:dc="http://purl.org/dc/elements/1.1/" xmlns:dcterms="http://purl.org/dc/terms/" xmlns:odoc="http://schemas.microsoft.com/internal/obd" targetNamespace="http://schemas.openxmlformats.org/package/2006/metadata/core-properties" elementFormDefault="qualified" attributeFormDefault="unqualified" blockDefault="#all">
+    <xsd:import namespace="http://purl.org/dc/elements/1.1/" schemaLocation="http://dublincore.org/schemas/xmls/qdc/2003/04/02/dc.xsd"/>
+    <xsd:import namespace="http://purl.org/dc/terms/" schemaLocation="http://dublincore.org/schemas/xmls/qdc/2003/04/02/dcterms.xsd"/>
+    <xsd:element name="coreProperties" type="CT_coreProperties"/>
+    <xsd:complexType name="CT_coreProperties">
+      <xsd:all>
+        <xsd:element ref="dc:creator" minOccurs="0" maxOccurs="1"/>
+        <xsd:element ref="dcterms:created" minOccurs="0" maxOccurs="1"/>
+        <xsd:element ref="dc:identifier" minOccurs="0" maxOccurs="1"/>
+        <xsd:element name="contentType" minOccurs="0" maxOccurs="1" type="xsd:string" ma:index="0" ma:displayName="Content Type"/>
+        <xsd:element ref="dc:title" minOccurs="0" maxOccurs="1" ma:index="4" ma:displayName="Title"/>
+        <xsd:element ref="dc:subject" minOccurs="0" maxOccurs="1"/>
+        <xsd:element ref="dc:description" minOccurs="0" maxOccurs="1"/>
+        <xsd:element name="keywords" minOccurs="0" maxOccurs="1" type="xsd:string"/>
+        <xsd:element ref="dc:language" minOccurs="0" maxOccurs="1"/>
+        <xsd:element name="category" minOccurs="0" maxOccurs="1" type="xsd:string"/>
+        <xsd:element name="version" minOccurs="0" maxOccurs="1" type="xsd:string"/>
+        <xsd:element name="revision" minOccurs="0" maxOccurs="1" type="xsd:string">
+          <xsd:annotation>
+            <xsd:documentation>
+                        This value indicates the number of saves or revisions. The application is responsible for updating this value after each revision.
+                    </xsd:documentation>
+          </xsd:annotation>
+        </xsd:element>
+        <xsd:element name="lastModifiedBy" minOccurs="0" maxOccurs="1" type="xsd:string"/>
+        <xsd:element ref="dcterms:modified" minOccurs="0" maxOccurs="1"/>
+        <xsd:element name="contentStatus" minOccurs="0" maxOccurs="1" type="xsd:string"/>
+      </xsd:all>
+    </xsd:complexType>
+  </xsd:schema>
+  <xs:schema xmlns:pc="http://schemas.microsoft.com/office/infopath/2007/PartnerControls" xmlns:xs="http://www.w3.org/2001/XMLSchema" targetNamespace="http://schemas.microsoft.com/office/infopath/2007/PartnerControls" elementFormDefault="qualified" attributeFormDefault="unqualified">
+    <xs:element name="Person">
+      <xs:complexType>
+        <xs:sequence>
+          <xs:element ref="pc:DisplayName" minOccurs="0"/>
+          <xs:element ref="pc:AccountId" minOccurs="0"/>
+          <xs:element ref="pc:AccountType" minOccurs="0"/>
+        </xs:sequence>
+      </xs:complexType>
+    </xs:element>
+    <xs:element name="DisplayName" type="xs:string"/>
+    <xs:element name="AccountId" type="xs:string"/>
+    <xs:element name="AccountType" type="xs:string"/>
+    <xs:element name="BDCAssociatedEntity">
+      <xs:complexType>
+        <xs:sequence>
+          <xs:element ref="pc:BDCEntity" minOccurs="0" maxOccurs="unbounded"/>
+        </xs:sequence>
+        <xs:attribute ref="pc:EntityNamespace"/>
+        <xs:attribute ref="pc:EntityName"/>
+        <xs:attribute ref="pc:SystemInstanceName"/>
+        <xs:attribute ref="pc:AssociationName"/>
+      </xs:complexType>
+    </xs:element>
+    <xs:attribute name="EntityNamespace" type="xs:string"/>
+    <xs:attribute name="EntityName" type="xs:string"/>
+    <xs:attribute name="SystemInstanceName" type="xs:string"/>
+    <xs:attribute name="AssociationName" type="xs:string"/>
+    <xs:element name="BDCEntity">
+      <xs:complexType>
+        <xs:sequence>
+          <xs:element ref="pc:EntityDisplayName" minOccurs="0"/>
+          <xs:element ref="pc:EntityInstanceReference" minOccurs="0"/>
+          <xs:element ref="pc:EntityId1" minOccurs="0"/>
+          <xs:element ref="pc:EntityId2" minOccurs="0"/>
+          <xs:element ref="pc:EntityId3" minOccurs="0"/>
+          <xs:element ref="pc:EntityId4" minOccurs="0"/>
+          <xs:element ref="pc:EntityId5" minOccurs="0"/>
+        </xs:sequence>
+      </xs:complexType>
+    </xs:element>
+    <xs:element name="EntityDisplayName" type="xs:string"/>
+    <xs:element name="EntityInstanceReference" type="xs:string"/>
+    <xs:element name="EntityId1" type="xs:string"/>
+    <xs:element name="EntityId2" type="xs:string"/>
+    <xs:element name="EntityId3" type="xs:string"/>
+    <xs:element name="EntityId4" type="xs:string"/>
+    <xs:element name="EntityId5" type="xs:string"/>
+    <xs:element name="Terms">
+      <xs:complexType>
+        <xs:sequence>
+          <xs:element ref="pc:TermInfo" minOccurs="0" maxOccurs="unbounded"/>
+        </xs:sequence>
+      </xs:complexType>
+    </xs:element>
+    <xs:element name="TermInfo">
+      <xs:complexType>
+        <xs:sequence>
+          <xs:element ref="pc:TermName" minOccurs="0"/>
+          <xs:element ref="pc:TermId" minOccurs="0"/>
+        </xs:sequence>
+      </xs:complexType>
+    </xs:element>
+    <xs:element name="TermName" type="xs:string"/>
+    <xs:element name="TermId" type="xs:string"/>
+  </xs:schema>
+</ct:contentTypeSchema>
+</file>
+
+<file path=customXml/item2.xml><?xml version="1.0" encoding="utf-8"?>
+<?mso-contentType ?>
+<FormTemplates xmlns="http://schemas.microsoft.com/sharepoint/v3/contenttype/forms">
+  <Display>DocumentLibraryForm</Display>
+  <Edit>DocumentLibraryForm</Edit>
+  <New>DocumentLibraryForm</New>
+</FormTemplates>
+</file>
+
+<file path=customXml/item3.xml><?xml version="1.0" encoding="utf-8"?>
+<p:properties xmlns:p="http://schemas.microsoft.com/office/2006/metadata/properties" xmlns:xsi="http://www.w3.org/2001/XMLSchema-instance" xmlns:pc="http://schemas.microsoft.com/office/infopath/2007/PartnerControls">
+  <documentManagement>
+    <lcf76f155ced4ddcb4097134ff3c332f xmlns="5749bc8e-1545-4b42-a651-f1b0ccdc5fa5">
+      <Terms xmlns="http://schemas.microsoft.com/office/infopath/2007/PartnerControls"/>
+    </lcf76f155ced4ddcb4097134ff3c332f>
+    <TaxCatchAll xmlns="8e022c51-0240-47ac-b7b0-09a2f3086777" xsi:nil="true"/>
+  </documentManagement>
+</p:properties>
+</file>
+
+<file path=customXml/itemProps1.xml><?xml version="1.0" encoding="utf-8"?>
+<ds:datastoreItem xmlns:ds="http://schemas.openxmlformats.org/officeDocument/2006/customXml" ds:itemID="{BC041A80-4E1D-44B6-8571-66800E147A98}"/>
+</file>
+
+<file path=customXml/itemProps2.xml><?xml version="1.0" encoding="utf-8"?>
+<ds:datastoreItem xmlns:ds="http://schemas.openxmlformats.org/officeDocument/2006/customXml" ds:itemID="{674222B3-251D-4087-85DD-B6D764A10599}"/>
+</file>
+
+<file path=customXml/itemProps3.xml><?xml version="1.0" encoding="utf-8"?>
+<ds:datastoreItem xmlns:ds="http://schemas.openxmlformats.org/officeDocument/2006/customXml" ds:itemID="{6EF9FED5-07F7-40DD-AC13-DE4D11902201}"/>
 </file>
</xml_diff>

<commit_message>
Address CDC feedback on Medication use MHS indicators
</commit_message>
<xml_diff>
--- a/CKDSurveillance/PPT/Q814.pptx
+++ b/CKDSurveillance/PPT/Q814.pptx
@@ -663,7 +663,7 @@
                 </a:r>
                 <a:r>
                   <a:rPr lang="en-US" dirty="0"/>
-                  <a:t>/ARB use (%)</a:t>
+                  <a:t>/ARB Use (%)</a:t>
                 </a:r>
               </a:p>
             </c:rich>
@@ -1015,7 +1015,7 @@
                 </a:r>
                 <a:r>
                   <a:rPr lang="en-US" baseline="0" dirty="0"/>
-                  <a:t> use (%)</a:t>
+                  <a:t> Use (%)</a:t>
                 </a:r>
                 <a:endParaRPr lang="en-US" dirty="0"/>
               </a:p>
@@ -2027,7 +2027,7 @@
                 </a:r>
                 <a:r>
                   <a:rPr lang="en-US" dirty="0"/>
-                  <a:t>/ARB use (%)</a:t>
+                  <a:t>/ARB Use (%)</a:t>
                 </a:r>
               </a:p>
             </c:rich>
@@ -2626,7 +2626,7 @@
                 </a:r>
                 <a:r>
                   <a:rPr lang="en-US" dirty="0"/>
-                  <a:t>/ARB use (%)</a:t>
+                  <a:t>/ARB Use (%)</a:t>
                 </a:r>
               </a:p>
             </c:rich>
@@ -3215,7 +3215,7 @@
                 </a:r>
                 <a:r>
                   <a:rPr lang="en-US" dirty="0"/>
-                  <a:t>/ARB use (%)</a:t>
+                  <a:t>/ARB Use (%)</a:t>
                 </a:r>
               </a:p>
             </c:rich>
@@ -4139,8 +4139,12 @@
                   </a:defRPr>
                 </a:pPr>
                 <a:r>
-                  <a:rPr lang="en-US"/>
-                  <a:t>ACEi/ARB use (%)</a:t>
+                  <a:rPr lang="en-US" dirty="0" err="1"/>
+                  <a:t>ACEi</a:t>
+                </a:r>
+                <a:r>
+                  <a:rPr lang="en-US" dirty="0"/>
+                  <a:t>/ARB Use (%)</a:t>
                 </a:r>
               </a:p>
             </c:rich>
@@ -5075,8 +5079,12 @@
                   </a:defRPr>
                 </a:pPr>
                 <a:r>
-                  <a:rPr lang="en-US"/>
-                  <a:t>ACEi/ARB use (%)</a:t>
+                  <a:rPr lang="en-US" dirty="0" err="1"/>
+                  <a:t>ACEi</a:t>
+                </a:r>
+                <a:r>
+                  <a:rPr lang="en-US" dirty="0"/>
+                  <a:t>/ARB Use (%)</a:t>
                 </a:r>
               </a:p>
             </c:rich>
@@ -5998,8 +6006,12 @@
                   </a:defRPr>
                 </a:pPr>
                 <a:r>
-                  <a:rPr lang="en-US"/>
-                  <a:t>ACEi/ARB use (%)</a:t>
+                  <a:rPr lang="en-US" dirty="0" err="1"/>
+                  <a:t>ACEi</a:t>
+                </a:r>
+                <a:r>
+                  <a:rPr lang="en-US" dirty="0"/>
+                  <a:t>/ARB Use (%)</a:t>
                 </a:r>
               </a:p>
             </c:rich>
@@ -6926,8 +6938,12 @@
                   </a:defRPr>
                 </a:pPr>
                 <a:r>
-                  <a:rPr lang="en-US"/>
-                  <a:t>ACEi/ARB use (%)</a:t>
+                  <a:rPr lang="en-US" dirty="0" err="1"/>
+                  <a:t>ACEi</a:t>
+                </a:r>
+                <a:r>
+                  <a:rPr lang="en-US" dirty="0"/>
+                  <a:t>/ARB Use (%)</a:t>
                 </a:r>
               </a:p>
             </c:rich>
@@ -12043,7 +12059,7 @@
           <a:p>
             <a:fld id="{0AF73B43-6A56-473B-AE2D-AB20CDBDB644}" type="datetimeFigureOut">
               <a:rPr lang="en-US" smtClean="0"/>
-              <a:t>2/20/2026</a:t>
+              <a:t>4/23/2026</a:t>
             </a:fld>
             <a:endParaRPr lang="en-US"/>
           </a:p>
@@ -12836,7 +12852,7 @@
           <a:p>
             <a:fld id="{740713D3-AB50-4A09-8DB2-7F26C27F2607}" type="datetimeFigureOut">
               <a:rPr lang="en-US" smtClean="0"/>
-              <a:t>2/20/2026</a:t>
+              <a:t>4/23/2026</a:t>
             </a:fld>
             <a:endParaRPr lang="en-US"/>
           </a:p>
@@ -13044,7 +13060,7 @@
           <a:p>
             <a:fld id="{740713D3-AB50-4A09-8DB2-7F26C27F2607}" type="datetimeFigureOut">
               <a:rPr lang="en-US" smtClean="0"/>
-              <a:t>2/20/2026</a:t>
+              <a:t>4/23/2026</a:t>
             </a:fld>
             <a:endParaRPr lang="en-US"/>
           </a:p>
@@ -13253,7 +13269,7 @@
           <a:p>
             <a:fld id="{740713D3-AB50-4A09-8DB2-7F26C27F2607}" type="datetimeFigureOut">
               <a:rPr lang="en-US" smtClean="0"/>
-              <a:t>2/20/2026</a:t>
+              <a:t>4/23/2026</a:t>
             </a:fld>
             <a:endParaRPr lang="en-US"/>
           </a:p>
@@ -13568,7 +13584,7 @@
           <a:p>
             <a:fld id="{740713D3-AB50-4A09-8DB2-7F26C27F2607}" type="datetimeFigureOut">
               <a:rPr lang="en-US" smtClean="0"/>
-              <a:t>2/20/2026</a:t>
+              <a:t>4/23/2026</a:t>
             </a:fld>
             <a:endParaRPr lang="en-US"/>
           </a:p>
@@ -13874,7 +13890,7 @@
           <a:p>
             <a:fld id="{740713D3-AB50-4A09-8DB2-7F26C27F2607}" type="datetimeFigureOut">
               <a:rPr lang="en-US" smtClean="0"/>
-              <a:t>2/20/2026</a:t>
+              <a:t>4/23/2026</a:t>
             </a:fld>
             <a:endParaRPr lang="en-US"/>
           </a:p>
@@ -14322,7 +14338,7 @@
           <a:p>
             <a:fld id="{740713D3-AB50-4A09-8DB2-7F26C27F2607}" type="datetimeFigureOut">
               <a:rPr lang="en-US" smtClean="0"/>
-              <a:t>2/20/2026</a:t>
+              <a:t>4/23/2026</a:t>
             </a:fld>
             <a:endParaRPr lang="en-US"/>
           </a:p>
@@ -14504,7 +14520,7 @@
           <a:p>
             <a:fld id="{740713D3-AB50-4A09-8DB2-7F26C27F2607}" type="datetimeFigureOut">
               <a:rPr lang="en-US" smtClean="0"/>
-              <a:t>2/20/2026</a:t>
+              <a:t>4/23/2026</a:t>
             </a:fld>
             <a:endParaRPr lang="en-US"/>
           </a:p>
@@ -14653,7 +14669,7 @@
           <a:p>
             <a:fld id="{740713D3-AB50-4A09-8DB2-7F26C27F2607}" type="datetimeFigureOut">
               <a:rPr lang="en-US" smtClean="0"/>
-              <a:t>2/20/2026</a:t>
+              <a:t>4/23/2026</a:t>
             </a:fld>
             <a:endParaRPr lang="en-US"/>
           </a:p>
@@ -15001,7 +15017,7 @@
           <a:p>
             <a:fld id="{740713D3-AB50-4A09-8DB2-7F26C27F2607}" type="datetimeFigureOut">
               <a:rPr lang="en-US" smtClean="0"/>
-              <a:t>2/20/2026</a:t>
+              <a:t>4/23/2026</a:t>
             </a:fld>
             <a:endParaRPr lang="en-US"/>
           </a:p>
@@ -15329,7 +15345,7 @@
           <a:p>
             <a:fld id="{740713D3-AB50-4A09-8DB2-7F26C27F2607}" type="datetimeFigureOut">
               <a:rPr lang="en-US" smtClean="0"/>
-              <a:t>2/20/2026</a:t>
+              <a:t>4/23/2026</a:t>
             </a:fld>
             <a:endParaRPr lang="en-US"/>
           </a:p>
@@ -15607,7 +15623,7 @@
           <a:p>
             <a:fld id="{740713D3-AB50-4A09-8DB2-7F26C27F2607}" type="datetimeFigureOut">
               <a:rPr lang="en-US" smtClean="0"/>
-              <a:t>2/20/2026</a:t>
+              <a:t>4/23/2026</a:t>
             </a:fld>
             <a:endParaRPr lang="en-US"/>
           </a:p>
@@ -16053,7 +16069,7 @@
             </a:r>
             <a:r>
               <a:rPr lang="en-US" dirty="0"/>
-              <a:t>/ARB use in Diabetes Mellitus With Chronic Kidney Disease in the Military Health System </a:t>
+              <a:t>/ARB Use in Diabetes Mellitus with CKD in the Military Health System </a:t>
             </a:r>
           </a:p>
         </p:txBody>
@@ -16083,31 +16099,43 @@
           <a:p>
             <a:pPr algn="l"/>
             <a:r>
-              <a:rPr lang="en-US" sz="2000" dirty="0"/>
+              <a:rPr lang="en-US" sz="2000" dirty="0">
+                <a:latin typeface="+mn-lt"/>
+              </a:rPr>
               <a:t>Angiotensin-converting enzyme inhibitor (</a:t>
             </a:r>
             <a:r>
-              <a:rPr lang="en-US" sz="2000" dirty="0" err="1"/>
+              <a:rPr lang="en-US" sz="2000" dirty="0" err="1">
+                <a:latin typeface="+mn-lt"/>
+              </a:rPr>
               <a:t>ACEi</a:t>
             </a:r>
             <a:r>
-              <a:rPr lang="en-US" sz="2000" dirty="0"/>
-              <a:t>) or angiotensin receptor blocker (ARB) use among Department of Defense Military Health System (DoD MHS) beneficiaries with types 1 and 2 diabetes mellitus and chronic kidney disease (CKD) decreased from 69.7% to 63.6% (age-standardized) between 2016 and 2023. Use was generally higher during the period among adults aged over 60 years (crude); males (age-standardized); adults who self-identified as Asian American/Pacific Islander (age-standardized); and those with CKD stage 1 (age-standardized).</a:t>
+              <a:rPr lang="en-US" sz="2000" dirty="0">
+                <a:latin typeface="+mn-lt"/>
+              </a:rPr>
+              <a:t>) or angiotensin receptor blocker (ARB) use among Military Health System (MHS) beneficiaries with types 1 and 2 diabetes mellitus and chronic kidney disease (CKD) decreased from 69.7% to 63.6% (age-standardized) between 2016 and 2023. Use was generally higher during the period among adults aged over 60 years (crude); males (age-standardized); adults who self-identified as Asian American/Pacific Islander (age-standardized); and those with CKD stage 1 (age-standardized).</a:t>
             </a:r>
           </a:p>
           <a:p>
             <a:pPr algn="l"/>
-            <a:endParaRPr lang="en-US" sz="2000" b="1" dirty="0"/>
+            <a:endParaRPr lang="en-US" sz="2000" b="1" dirty="0">
+              <a:latin typeface="+mn-lt"/>
+            </a:endParaRPr>
           </a:p>
           <a:p>
             <a:pPr algn="l"/>
             <a:r>
-              <a:rPr lang="en-US" sz="2000" b="1" dirty="0"/>
+              <a:rPr lang="en-US" sz="2000" b="1" dirty="0">
+                <a:latin typeface="+mn-lt"/>
+              </a:rPr>
               <a:t>Data Source: </a:t>
             </a:r>
             <a:r>
-              <a:rPr lang="en-US" sz="2000" dirty="0"/>
-              <a:t>DoD-MHS  </a:t>
+              <a:rPr lang="en-US" sz="2000" dirty="0">
+                <a:latin typeface="+mn-lt"/>
+              </a:rPr>
+              <a:t>MHS  </a:t>
             </a:r>
           </a:p>
         </p:txBody>
@@ -16182,7 +16210,7 @@
             </a:r>
             <a:r>
               <a:rPr lang="en-US" dirty="0"/>
-              <a:t>/ARB use in DM with CKD by CKD Stage, Age Standardized</a:t>
+              <a:t>/ARB Use in DM with CKD by CKD Stage, Age Standardized</a:t>
             </a:r>
           </a:p>
         </p:txBody>
@@ -16202,7 +16230,7 @@
           <p:nvPr>
             <p:extLst>
               <p:ext uri="{D42A27DB-BD31-4B8C-83A1-F6EECF244321}">
-                <p14:modId xmlns:p14="http://schemas.microsoft.com/office/powerpoint/2010/main" val="1632729165"/>
+                <p14:modId xmlns:p14="http://schemas.microsoft.com/office/powerpoint/2010/main" val="3204128926"/>
               </p:ext>
             </p:extLst>
           </p:nvPr>
@@ -16287,7 +16315,7 @@
             </a:r>
             <a:r>
               <a:rPr lang="en-US" dirty="0"/>
-              <a:t>/ARB use in DM with CKD, Crude</a:t>
+              <a:t>/ARB Use in DM with CKD, Crude</a:t>
             </a:r>
           </a:p>
         </p:txBody>
@@ -16307,7 +16335,7 @@
           <p:nvPr>
             <p:extLst>
               <p:ext uri="{D42A27DB-BD31-4B8C-83A1-F6EECF244321}">
-                <p14:modId xmlns:p14="http://schemas.microsoft.com/office/powerpoint/2010/main" val="2347014995"/>
+                <p14:modId xmlns:p14="http://schemas.microsoft.com/office/powerpoint/2010/main" val="4280133633"/>
               </p:ext>
             </p:extLst>
           </p:nvPr>
@@ -16392,7 +16420,7 @@
             </a:r>
             <a:r>
               <a:rPr lang="en-US" dirty="0"/>
-              <a:t>/ARB use in DM with CKD, Age Standardized</a:t>
+              <a:t>/ARB Use in DM with CKD, Age Standardized</a:t>
             </a:r>
           </a:p>
         </p:txBody>
@@ -16412,7 +16440,7 @@
           <p:nvPr>
             <p:extLst>
               <p:ext uri="{D42A27DB-BD31-4B8C-83A1-F6EECF244321}">
-                <p14:modId xmlns:p14="http://schemas.microsoft.com/office/powerpoint/2010/main" val="3682137251"/>
+                <p14:modId xmlns:p14="http://schemas.microsoft.com/office/powerpoint/2010/main" val="818845843"/>
               </p:ext>
             </p:extLst>
           </p:nvPr>
@@ -16491,7 +16519,7 @@
             </a:r>
             <a:r>
               <a:rPr lang="en-US" dirty="0"/>
-              <a:t>/ARB use in DM with CKD, by Age</a:t>
+              <a:t>/ARB Use in DM with CKD, by Age</a:t>
             </a:r>
           </a:p>
         </p:txBody>
@@ -16511,7 +16539,7 @@
           <p:nvPr>
             <p:extLst>
               <p:ext uri="{D42A27DB-BD31-4B8C-83A1-F6EECF244321}">
-                <p14:modId xmlns:p14="http://schemas.microsoft.com/office/powerpoint/2010/main" val="1764000342"/>
+                <p14:modId xmlns:p14="http://schemas.microsoft.com/office/powerpoint/2010/main" val="3665143539"/>
               </p:ext>
             </p:extLst>
           </p:nvPr>
@@ -16596,7 +16624,7 @@
             </a:r>
             <a:r>
               <a:rPr lang="en-US" dirty="0"/>
-              <a:t>/ARB use in DM with CKD by Sex, Crude</a:t>
+              <a:t>/ARB Use in DM with CKD by Sex, Crude</a:t>
             </a:r>
           </a:p>
         </p:txBody>
@@ -16616,7 +16644,7 @@
           <p:nvPr>
             <p:extLst>
               <p:ext uri="{D42A27DB-BD31-4B8C-83A1-F6EECF244321}">
-                <p14:modId xmlns:p14="http://schemas.microsoft.com/office/powerpoint/2010/main" val="490948724"/>
+                <p14:modId xmlns:p14="http://schemas.microsoft.com/office/powerpoint/2010/main" val="997613931"/>
               </p:ext>
             </p:extLst>
           </p:nvPr>
@@ -16701,7 +16729,7 @@
             </a:r>
             <a:r>
               <a:rPr lang="en-US" dirty="0"/>
-              <a:t>/ARB use in DM with CKD by Sex, Age Standardized</a:t>
+              <a:t>/ARB Use in DM with CKD by Sex, Age Standardized</a:t>
             </a:r>
           </a:p>
         </p:txBody>
@@ -16721,7 +16749,7 @@
           <p:nvPr>
             <p:extLst>
               <p:ext uri="{D42A27DB-BD31-4B8C-83A1-F6EECF244321}">
-                <p14:modId xmlns:p14="http://schemas.microsoft.com/office/powerpoint/2010/main" val="1207573094"/>
+                <p14:modId xmlns:p14="http://schemas.microsoft.com/office/powerpoint/2010/main" val="2845058569"/>
               </p:ext>
             </p:extLst>
           </p:nvPr>
@@ -16806,7 +16834,7 @@
             </a:r>
             <a:r>
               <a:rPr lang="en-US" dirty="0"/>
-              <a:t>/ARB use in DM with CKD by Race, Crude</a:t>
+              <a:t>/ARB Use in DM with CKD by Race, Crude</a:t>
             </a:r>
           </a:p>
         </p:txBody>
@@ -16826,7 +16854,7 @@
           <p:nvPr>
             <p:extLst>
               <p:ext uri="{D42A27DB-BD31-4B8C-83A1-F6EECF244321}">
-                <p14:modId xmlns:p14="http://schemas.microsoft.com/office/powerpoint/2010/main" val="1092530866"/>
+                <p14:modId xmlns:p14="http://schemas.microsoft.com/office/powerpoint/2010/main" val="1731942718"/>
               </p:ext>
             </p:extLst>
           </p:nvPr>
@@ -16911,7 +16939,7 @@
             </a:r>
             <a:r>
               <a:rPr lang="en-US" dirty="0"/>
-              <a:t>/ARB use in DM with CKD by Race, </a:t>
+              <a:t>/ARB Use in DM with CKD by Race, </a:t>
             </a:r>
             <a:br>
               <a:rPr lang="en-US" dirty="0"/>
@@ -16938,7 +16966,7 @@
           <p:nvPr>
             <p:extLst>
               <p:ext uri="{D42A27DB-BD31-4B8C-83A1-F6EECF244321}">
-                <p14:modId xmlns:p14="http://schemas.microsoft.com/office/powerpoint/2010/main" val="1841575661"/>
+                <p14:modId xmlns:p14="http://schemas.microsoft.com/office/powerpoint/2010/main" val="971973852"/>
               </p:ext>
             </p:extLst>
           </p:nvPr>
@@ -17023,7 +17051,7 @@
             </a:r>
             <a:r>
               <a:rPr lang="en-US" dirty="0"/>
-              <a:t>/ARB use in DM with CKD by CKD Stage, Crude</a:t>
+              <a:t>/ARB Use in DM with CKD by CKD Stage, Crude</a:t>
             </a:r>
           </a:p>
         </p:txBody>
@@ -17043,7 +17071,7 @@
           <p:nvPr>
             <p:extLst>
               <p:ext uri="{D42A27DB-BD31-4B8C-83A1-F6EECF244321}">
-                <p14:modId xmlns:p14="http://schemas.microsoft.com/office/powerpoint/2010/main" val="1145563012"/>
+                <p14:modId xmlns:p14="http://schemas.microsoft.com/office/powerpoint/2010/main" val="131750670"/>
               </p:ext>
             </p:extLst>
           </p:nvPr>
@@ -19074,225 +19102,4 @@
     </a:bgFillStyleLst>
   </a:fmtScheme>
 </a:themeOverride>
-</file>
-
-<file path=customXml/item1.xml><?xml version="1.0" encoding="utf-8"?>
-<ct:contentTypeSchema xmlns:ct="http://schemas.microsoft.com/office/2006/metadata/contentType" xmlns:ma="http://schemas.microsoft.com/office/2006/metadata/properties/metaAttributes" ct:_="" ma:_="" ma:contentTypeName="Document" ma:contentTypeID="0x01010050BC9B24C2BC4648A822105B302116B0" ma:contentTypeVersion="10" ma:contentTypeDescription="Create a new document." ma:contentTypeScope="" ma:versionID="581fb2d9703863f3db532522de69a7d8">
-  <xsd:schema xmlns:xsd="http://www.w3.org/2001/XMLSchema" xmlns:xs="http://www.w3.org/2001/XMLSchema" xmlns:p="http://schemas.microsoft.com/office/2006/metadata/properties" xmlns:ns2="5749bc8e-1545-4b42-a651-f1b0ccdc5fa5" xmlns:ns3="8e022c51-0240-47ac-b7b0-09a2f3086777" targetNamespace="http://schemas.microsoft.com/office/2006/metadata/properties" ma:root="true" ma:fieldsID="96cb22f3222442646e545c3c1fc94001" ns2:_="" ns3:_="">
-    <xsd:import namespace="5749bc8e-1545-4b42-a651-f1b0ccdc5fa5"/>
-    <xsd:import namespace="8e022c51-0240-47ac-b7b0-09a2f3086777"/>
-    <xsd:element name="properties">
-      <xsd:complexType>
-        <xsd:sequence>
-          <xsd:element name="documentManagement">
-            <xsd:complexType>
-              <xsd:all>
-                <xsd:element ref="ns2:MediaServiceMetadata" minOccurs="0"/>
-                <xsd:element ref="ns2:MediaServiceFastMetadata" minOccurs="0"/>
-                <xsd:element ref="ns2:MediaServiceSearchProperties" minOccurs="0"/>
-                <xsd:element ref="ns2:MediaServiceDateTaken" minOccurs="0"/>
-                <xsd:element ref="ns2:lcf76f155ced4ddcb4097134ff3c332f" minOccurs="0"/>
-                <xsd:element ref="ns3:TaxCatchAll" minOccurs="0"/>
-                <xsd:element ref="ns2:MediaServiceOCR" minOccurs="0"/>
-                <xsd:element ref="ns2:MediaServiceGenerationTime" minOccurs="0"/>
-                <xsd:element ref="ns2:MediaServiceEventHashCode" minOccurs="0"/>
-              </xsd:all>
-            </xsd:complexType>
-          </xsd:element>
-        </xsd:sequence>
-      </xsd:complexType>
-    </xsd:element>
-  </xsd:schema>
-  <xsd:schema xmlns:xsd="http://www.w3.org/2001/XMLSchema" xmlns:xs="http://www.w3.org/2001/XMLSchema" xmlns:dms="http://schemas.microsoft.com/office/2006/documentManagement/types" xmlns:pc="http://schemas.microsoft.com/office/infopath/2007/PartnerControls" targetNamespace="5749bc8e-1545-4b42-a651-f1b0ccdc5fa5" elementFormDefault="qualified">
-    <xsd:import namespace="http://schemas.microsoft.com/office/2006/documentManagement/types"/>
-    <xsd:import namespace="http://schemas.microsoft.com/office/infopath/2007/PartnerControls"/>
-    <xsd:element name="MediaServiceMetadata" ma:index="8" nillable="true" ma:displayName="MediaServiceMetadata" ma:hidden="true" ma:internalName="MediaServiceMetadata" ma:readOnly="true">
-      <xsd:simpleType>
-        <xsd:restriction base="dms:Note"/>
-      </xsd:simpleType>
-    </xsd:element>
-    <xsd:element name="MediaServiceFastMetadata" ma:index="9" nillable="true" ma:displayName="MediaServiceFastMetadata" ma:hidden="true" ma:internalName="MediaServiceFastMetadata" ma:readOnly="true">
-      <xsd:simpleType>
-        <xsd:restriction base="dms:Note"/>
-      </xsd:simpleType>
-    </xsd:element>
-    <xsd:element name="MediaServiceSearchProperties" ma:index="10" nillable="true" ma:displayName="MediaServiceSearchProperties" ma:hidden="true" ma:internalName="MediaServiceSearchProperties" ma:readOnly="true">
-      <xsd:simpleType>
-        <xsd:restriction base="dms:Note"/>
-      </xsd:simpleType>
-    </xsd:element>
-    <xsd:element name="MediaServiceDateTaken" ma:index="11" nillable="true" ma:displayName="MediaServiceDateTaken" ma:hidden="true" ma:indexed="true" ma:internalName="MediaServiceDateTaken" ma:readOnly="true">
-      <xsd:simpleType>
-        <xsd:restriction base="dms:Text"/>
-      </xsd:simpleType>
-    </xsd:element>
-    <xsd:element name="lcf76f155ced4ddcb4097134ff3c332f" ma:index="13" nillable="true" ma:taxonomy="true" ma:internalName="lcf76f155ced4ddcb4097134ff3c332f" ma:taxonomyFieldName="MediaServiceImageTags" ma:displayName="Image Tags" ma:readOnly="false" ma:fieldId="{5cf76f15-5ced-4ddc-b409-7134ff3c332f}" ma:taxonomyMulti="true" ma:sspId="cae6c5d7-b21f-4aaa-ac91-296ecc6194c0" ma:termSetId="09814cd3-568e-fe90-9814-8d621ff8fb84" ma:anchorId="fba54fb3-c3e1-fe81-a776-ca4b69148c4d" ma:open="true" ma:isKeyword="false">
-      <xsd:complexType>
-        <xsd:sequence>
-          <xsd:element ref="pc:Terms" minOccurs="0" maxOccurs="1"/>
-        </xsd:sequence>
-      </xsd:complexType>
-    </xsd:element>
-    <xsd:element name="MediaServiceOCR" ma:index="15" nillable="true" ma:displayName="Extracted Text" ma:internalName="MediaServiceOCR" ma:readOnly="true">
-      <xsd:simpleType>
-        <xsd:restriction base="dms:Note">
-          <xsd:maxLength value="255"/>
-        </xsd:restriction>
-      </xsd:simpleType>
-    </xsd:element>
-    <xsd:element name="MediaServiceGenerationTime" ma:index="16" nillable="true" ma:displayName="MediaServiceGenerationTime" ma:hidden="true" ma:internalName="MediaServiceGenerationTime" ma:readOnly="true">
-      <xsd:simpleType>
-        <xsd:restriction base="dms:Text"/>
-      </xsd:simpleType>
-    </xsd:element>
-    <xsd:element name="MediaServiceEventHashCode" ma:index="17" nillable="true" ma:displayName="MediaServiceEventHashCode" ma:hidden="true" ma:internalName="MediaServiceEventHashCode" ma:readOnly="true">
-      <xsd:simpleType>
-        <xsd:restriction base="dms:Text"/>
-      </xsd:simpleType>
-    </xsd:element>
-  </xsd:schema>
-  <xsd:schema xmlns:xsd="http://www.w3.org/2001/XMLSchema" xmlns:xs="http://www.w3.org/2001/XMLSchema" xmlns:dms="http://schemas.microsoft.com/office/2006/documentManagement/types" xmlns:pc="http://schemas.microsoft.com/office/infopath/2007/PartnerControls" targetNamespace="8e022c51-0240-47ac-b7b0-09a2f3086777" elementFormDefault="qualified">
-    <xsd:import namespace="http://schemas.microsoft.com/office/2006/documentManagement/types"/>
-    <xsd:import namespace="http://schemas.microsoft.com/office/infopath/2007/PartnerControls"/>
-    <xsd:element name="TaxCatchAll" ma:index="14" nillable="true" ma:displayName="Taxonomy Catch All Column" ma:hidden="true" ma:list="{4f07c378-3462-46dc-a28e-833745c64bfd}" ma:internalName="TaxCatchAll" ma:showField="CatchAllData" ma:web="8e022c51-0240-47ac-b7b0-09a2f3086777">
-      <xsd:complexType>
-        <xsd:complexContent>
-          <xsd:extension base="dms:MultiChoiceLookup">
-            <xsd:sequence>
-              <xsd:element name="Value" type="dms:Lookup" maxOccurs="unbounded" minOccurs="0" nillable="true"/>
-            </xsd:sequence>
-          </xsd:extension>
-        </xsd:complexContent>
-      </xsd:complexType>
-    </xsd:element>
-  </xsd:schema>
-  <xsd:schema xmlns="http://schemas.openxmlformats.org/package/2006/metadata/core-properties" xmlns:xsd="http://www.w3.org/2001/XMLSchema" xmlns:xsi="http://www.w3.org/2001/XMLSchema-instance" xmlns:dc="http://purl.org/dc/elements/1.1/" xmlns:dcterms="http://purl.org/dc/terms/" xmlns:odoc="http://schemas.microsoft.com/internal/obd" targetNamespace="http://schemas.openxmlformats.org/package/2006/metadata/core-properties" elementFormDefault="qualified" attributeFormDefault="unqualified" blockDefault="#all">
-    <xsd:import namespace="http://purl.org/dc/elements/1.1/" schemaLocation="http://dublincore.org/schemas/xmls/qdc/2003/04/02/dc.xsd"/>
-    <xsd:import namespace="http://purl.org/dc/terms/" schemaLocation="http://dublincore.org/schemas/xmls/qdc/2003/04/02/dcterms.xsd"/>
-    <xsd:element name="coreProperties" type="CT_coreProperties"/>
-    <xsd:complexType name="CT_coreProperties">
-      <xsd:all>
-        <xsd:element ref="dc:creator" minOccurs="0" maxOccurs="1"/>
-        <xsd:element ref="dcterms:created" minOccurs="0" maxOccurs="1"/>
-        <xsd:element ref="dc:identifier" minOccurs="0" maxOccurs="1"/>
-        <xsd:element name="contentType" minOccurs="0" maxOccurs="1" type="xsd:string" ma:index="0" ma:displayName="Content Type"/>
-        <xsd:element ref="dc:title" minOccurs="0" maxOccurs="1" ma:index="4" ma:displayName="Title"/>
-        <xsd:element ref="dc:subject" minOccurs="0" maxOccurs="1"/>
-        <xsd:element ref="dc:description" minOccurs="0" maxOccurs="1"/>
-        <xsd:element name="keywords" minOccurs="0" maxOccurs="1" type="xsd:string"/>
-        <xsd:element ref="dc:language" minOccurs="0" maxOccurs="1"/>
-        <xsd:element name="category" minOccurs="0" maxOccurs="1" type="xsd:string"/>
-        <xsd:element name="version" minOccurs="0" maxOccurs="1" type="xsd:string"/>
-        <xsd:element name="revision" minOccurs="0" maxOccurs="1" type="xsd:string">
-          <xsd:annotation>
-            <xsd:documentation>
-                        This value indicates the number of saves or revisions. The application is responsible for updating this value after each revision.
-                    </xsd:documentation>
-          </xsd:annotation>
-        </xsd:element>
-        <xsd:element name="lastModifiedBy" minOccurs="0" maxOccurs="1" type="xsd:string"/>
-        <xsd:element ref="dcterms:modified" minOccurs="0" maxOccurs="1"/>
-        <xsd:element name="contentStatus" minOccurs="0" maxOccurs="1" type="xsd:string"/>
-      </xsd:all>
-    </xsd:complexType>
-  </xsd:schema>
-  <xs:schema xmlns:pc="http://schemas.microsoft.com/office/infopath/2007/PartnerControls" xmlns:xs="http://www.w3.org/2001/XMLSchema" targetNamespace="http://schemas.microsoft.com/office/infopath/2007/PartnerControls" elementFormDefault="qualified" attributeFormDefault="unqualified">
-    <xs:element name="Person">
-      <xs:complexType>
-        <xs:sequence>
-          <xs:element ref="pc:DisplayName" minOccurs="0"/>
-          <xs:element ref="pc:AccountId" minOccurs="0"/>
-          <xs:element ref="pc:AccountType" minOccurs="0"/>
-        </xs:sequence>
-      </xs:complexType>
-    </xs:element>
-    <xs:element name="DisplayName" type="xs:string"/>
-    <xs:element name="AccountId" type="xs:string"/>
-    <xs:element name="AccountType" type="xs:string"/>
-    <xs:element name="BDCAssociatedEntity">
-      <xs:complexType>
-        <xs:sequence>
-          <xs:element ref="pc:BDCEntity" minOccurs="0" maxOccurs="unbounded"/>
-        </xs:sequence>
-        <xs:attribute ref="pc:EntityNamespace"/>
-        <xs:attribute ref="pc:EntityName"/>
-        <xs:attribute ref="pc:SystemInstanceName"/>
-        <xs:attribute ref="pc:AssociationName"/>
-      </xs:complexType>
-    </xs:element>
-    <xs:attribute name="EntityNamespace" type="xs:string"/>
-    <xs:attribute name="EntityName" type="xs:string"/>
-    <xs:attribute name="SystemInstanceName" type="xs:string"/>
-    <xs:attribute name="AssociationName" type="xs:string"/>
-    <xs:element name="BDCEntity">
-      <xs:complexType>
-        <xs:sequence>
-          <xs:element ref="pc:EntityDisplayName" minOccurs="0"/>
-          <xs:element ref="pc:EntityInstanceReference" minOccurs="0"/>
-          <xs:element ref="pc:EntityId1" minOccurs="0"/>
-          <xs:element ref="pc:EntityId2" minOccurs="0"/>
-          <xs:element ref="pc:EntityId3" minOccurs="0"/>
-          <xs:element ref="pc:EntityId4" minOccurs="0"/>
-          <xs:element ref="pc:EntityId5" minOccurs="0"/>
-        </xs:sequence>
-      </xs:complexType>
-    </xs:element>
-    <xs:element name="EntityDisplayName" type="xs:string"/>
-    <xs:element name="EntityInstanceReference" type="xs:string"/>
-    <xs:element name="EntityId1" type="xs:string"/>
-    <xs:element name="EntityId2" type="xs:string"/>
-    <xs:element name="EntityId3" type="xs:string"/>
-    <xs:element name="EntityId4" type="xs:string"/>
-    <xs:element name="EntityId5" type="xs:string"/>
-    <xs:element name="Terms">
-      <xs:complexType>
-        <xs:sequence>
-          <xs:element ref="pc:TermInfo" minOccurs="0" maxOccurs="unbounded"/>
-        </xs:sequence>
-      </xs:complexType>
-    </xs:element>
-    <xs:element name="TermInfo">
-      <xs:complexType>
-        <xs:sequence>
-          <xs:element ref="pc:TermName" minOccurs="0"/>
-          <xs:element ref="pc:TermId" minOccurs="0"/>
-        </xs:sequence>
-      </xs:complexType>
-    </xs:element>
-    <xs:element name="TermName" type="xs:string"/>
-    <xs:element name="TermId" type="xs:string"/>
-  </xs:schema>
-</ct:contentTypeSchema>
-</file>
-
-<file path=customXml/item2.xml><?xml version="1.0" encoding="utf-8"?>
-<?mso-contentType ?>
-<FormTemplates xmlns="http://schemas.microsoft.com/sharepoint/v3/contenttype/forms">
-  <Display>DocumentLibraryForm</Display>
-  <Edit>DocumentLibraryForm</Edit>
-  <New>DocumentLibraryForm</New>
-</FormTemplates>
-</file>
-
-<file path=customXml/item3.xml><?xml version="1.0" encoding="utf-8"?>
-<p:properties xmlns:p="http://schemas.microsoft.com/office/2006/metadata/properties" xmlns:xsi="http://www.w3.org/2001/XMLSchema-instance" xmlns:pc="http://schemas.microsoft.com/office/infopath/2007/PartnerControls">
-  <documentManagement>
-    <lcf76f155ced4ddcb4097134ff3c332f xmlns="5749bc8e-1545-4b42-a651-f1b0ccdc5fa5">
-      <Terms xmlns="http://schemas.microsoft.com/office/infopath/2007/PartnerControls"/>
-    </lcf76f155ced4ddcb4097134ff3c332f>
-    <TaxCatchAll xmlns="8e022c51-0240-47ac-b7b0-09a2f3086777" xsi:nil="true"/>
-  </documentManagement>
-</p:properties>
-</file>
-
-<file path=customXml/itemProps1.xml><?xml version="1.0" encoding="utf-8"?>
-<ds:datastoreItem xmlns:ds="http://schemas.openxmlformats.org/officeDocument/2006/customXml" ds:itemID="{BC041A80-4E1D-44B6-8571-66800E147A98}"/>
-</file>
-
-<file path=customXml/itemProps2.xml><?xml version="1.0" encoding="utf-8"?>
-<ds:datastoreItem xmlns:ds="http://schemas.openxmlformats.org/officeDocument/2006/customXml" ds:itemID="{674222B3-251D-4087-85DD-B6D764A10599}"/>
-</file>
-
-<file path=customXml/itemProps3.xml><?xml version="1.0" encoding="utf-8"?>
-<ds:datastoreItem xmlns:ds="http://schemas.openxmlformats.org/officeDocument/2006/customXml" ds:itemID="{6EF9FED5-07F7-40DD-AC13-DE4D11902201}"/>
 </file>
</xml_diff>